<commit_message>
E-080 revision 2: 1° geometry maps with a coarse+residual prior; no Argo ellipses
After a second agent's review and Chris's decision: the learnable cone's
parameter maps move from 2° to 1° (coarse 10° map plus a 1° residual under
L2 shrinkage and Laplacian smoothness), and the three Argo depth maps are
dropped — Argo arrives as nearest-profile tokens, which have no ellipse to
learn; depth-dependent sourcing is an attention diagnostic (R4). Slides 10,
11, 12, 14, 15, 16, 17 and the AMOC figure updated. Still design only.

Co-Authored-By: Claude Fable 5.1 <noreply@anthropic.com>
Claude-Session: https://claude.ai/code/session_01D2J1M6bHDVYWvgiF1PyUvg
</commit_message>
<xml_diff>
--- a/ml/plans/E080_hourglass_cone_deck.pptx
+++ b/ml/plans/E080_hourglass_cone_deck.pptx
@@ -607,7 +607,7 @@
           <a:p>
             <a:r>
               <a:rPr lang="en-US" dirty="0"/>
-              <a:t>Where do the seven numbers live? On a coarse map. A two-degree grid over the globe has sixteen thousand cells; an anchor takes the blend of the four cells around it, so the geometry varies smoothly and never jumps at a cell edge. There is one such map per channel group, because what moves a signal decides where its source is. The ocean surface group is moved by the surface currents. The Argo groups are split by depth into upper, mid and deep, because the ocean's layers move in different directions — at the RAPID line, where the AMOC is measured, the upper limb flows north and the Deep Western Boundary Current flows south, so the very same anchor should point its surface cone toward the south and its deep cone toward the north. The atmosphere group only has drift at the two lags inside its ten-day memory. The land group has no drift at all: soil moisture does not advect, so it learns only the axes and the angle. All told that is about seven hundred thousand numbers, a tenth of the seven-million codec. A phase-two option is a seasonal term on the drift — one harmonic of the day of year — because the Somali Current reverses with the monsoon and one arrow per region cannot say that.</a:t>
+              <a:t>Where do the seven numbers live? On a one-degree map. A one-degree grid over the globe has about sixty-five thousand cells; an anchor takes the blend of the four cells around it, so the geometry varies smoothly and never jumps at a cell edge. One degree is not a round number picked for comfort: the currents that carry the overturning are about a hundred kilometres wide — the Florida Current runs through an eighty-kilometre strait — and a ten-degree cell would average the Gulf Stream with the water flowing back the other way beside it and learn an arrow of nearly zero. The concern with a fine map is noise in cells that see little data, at the ice edge or along coasts. The answer is a hierarchical prior rather than a coarser map: every map is a coarse ten-degree map plus a one-degree residual, and the residual is shrunk toward zero and smoothed toward its neighbours, so a cell with little evidence inherits the arrow of its region. Even so, each one-degree cell sees about fifty thousand anchor-pentads for its seven numbers. There is one map per channel group, because what moves a signal decides where its source is: the ocean surface group, the atmosphere group with drift only inside its ten-day memory, and the land group, which does not advect and learns only axes and angle. Argo gets no map at all. Its channels arrive as the nearest profile tokens, placed where the floats actually were, each carrying its own offset, age and depth — there is no ellipse there to learn, and the earlier draft's three depth maps were a leftover from the column-only Argo of E-069. The physics that motivated them still matters — at the RAPID line the upper limb flows north and the deep boundary current south — but a token that carries its own depth and offset lets attention weight deep tokens from the north and surface tokens from the south by itself. That becomes a diagnostic rather than a geometry. All told the maps hold about one and a half million numbers, half of them live, and they cost no compute.</a:t>
             </a:r>
             <a:endParaRPr lang="en-US" dirty="0"/>
           </a:p>
@@ -695,7 +695,7 @@
           <a:p>
             <a:r>
               <a:rPr lang="en-US" dirty="0"/>
-              <a:t>The seven numbers are bounded by physics and tied to the fixed cone. The drift cannot exceed the design speed cone v2 set — the fastest measured current times one and a half, about two thousand three hundred kilometres per pentad — so the learned cone always lives inside the envelope v2 argued for. The axes cannot shrink below one cell or grow faster than the design speed. The future cone shares the numbers, reflected; letting it have its own is an ablation. Two guards protect the learning itself. First, the loss reaches the geometry only through the input reads; where a target sits is treated as a constant. Without that, the model would learn to move its questions to wherever they are easiest, and a cone that points at flat water would look excellent. Second, the v2 safety net stays: alongside the learned ellipse, every lag keeps one fixed ring of twenty-four dots at log-spaced radii to the far side of the planet. That is the point of v2 — a cone that is too narrow silently asserts that a driver could not have arrived — and the learned ellipse adds direction and density on top of it rather than replacing it. And the initial values reproduce the fixed hourglass exactly, so the learned arm starts as the control and every departure from it is something the data asked for.</a:t>
+              <a:t>The seven numbers are bounded by physics and tied to the fixed cone. The drift cannot exceed the design speed cone v2 set — the fastest measured current times one and a half, about two thousand three hundred kilometres per pentad — so the learned cone always lives inside the envelope v2 argued for. The axes cannot shrink below one cell or grow faster than the design speed. The one-degree residual is shrunk and smoothed under a single prior weight that the run records. The future cone shares the numbers, reflected; letting it have its own is an ablation. Two guards protect the learning itself. First, the loss reaches the geometry only through the input reads; where a target sits is treated as a constant. Without that, the model would learn to move its questions to wherever they are easiest, and a cone that points at flat water would look excellent. Second, the v2 safety net stays: alongside the learned ellipse, every lag keeps one fixed ring of twenty-four dots at log-spaced radii to the far side of the planet. That is the point of v2 — a cone that is too narrow silently asserts that a driver could not have arrived — and the learned ellipse adds direction and density on top of it rather than replacing it. And the initial values reproduce the fixed hourglass exactly, so the learned arm starts as the control and every departure from it is something the data asked for.</a:t>
             </a:r>
             <a:endParaRPr lang="en-US" dirty="0"/>
           </a:p>
@@ -783,7 +783,7 @@
           <a:p>
             <a:r>
               <a:rPr lang="en-US" dirty="0"/>
-              <a:t>Here is the picture Chris asked for, drawn as we expect the model to draw it. An anchor on the western boundary just north of the RAPID line. For the surface group, water arrives up the Florida Current from the Caribbean, so the past cone should drift south-west, growing as it goes back, and the future cone should lean north-east along the Gulf Stream. For the deep group, the Deep Western Boundary Current runs the other way along the continental slope, so the past cone should drift north toward the Grand Banks and the future cone south. Neither arrow is programmed. They are what we expect the maps to show if the mechanism works, and they are written down now, before any run, so the check cannot be shaped by the result. The world-ocean version of the check is a single number: the correlation between the learned surface drift and the climatological surface current reversed, over cells where that current is at least a fifth of a metre per second. A clearly positive value means the cone learned "upstream" from the data alone. And the faint ring around the anchor is the fixed v2 safety net — always there, never learned, so nothing the model does can wall off a direction.</a:t>
+              <a:t>Here is the picture Chris asked for, drawn as we expect the model to draw it. An anchor on the western boundary just north of the RAPID line. For the surface group, water arrives up the Florida Current from the Caribbean, so the past cone should drift south-west, growing as it goes back, and the future cone should lean north-east along the Gulf Stream. The deep ocean is read differently, because Argo has no ellipse: the anchor sees the nearest profiles within the search radius, each token saying where it was, how old it is and how deep. The Deep Western Boundary Current runs the other way along the continental slope, so if the model has understood the deep ocean, its attention on deep profiles should sit north of the anchor, toward the Grand Banks, while its attention on shallow profiles sits south. Neither is programmed. They are what we expect to see if the mechanism works — a geometry check for the surface, an attention check for the deep — and they are written down now, before any run, so the check cannot be shaped by the result. The world-ocean version of the surface check is a single number: the correlation between the learned surface drift and the climatological surface current reversed, over cells where that current is at least a fifth of a metre per second. A clearly positive value means the cone learned "upstream" from the data alone. And the faint ring around the anchor is the fixed v2 safety net — always there, never learned, so nothing the model does can wall off a direction.</a:t>
             </a:r>
             <a:endParaRPr lang="en-US" dirty="0"/>
           </a:p>
@@ -959,7 +959,7 @@
           <a:p>
             <a:r>
               <a:rPr lang="en-US" dirty="0"/>
-              <a:t>What it costs, in the same units as the earlier decks. The waist is thirteen per-location tokens each carrying all surface channels, which is fewer than the forty-two per-channel patch tokens E-069 used. The past cone is six lags of one anchor column, twenty-four ellipse dots and twenty-four ring dots, for four channel groups — about twelve hundred tokens. Argo comes as the twenty-six profile tokens cone v2 already specified. Targets are drawn as two hundred and fifty-six decoder queries per example, as now. The geometry adds about seven hundred thousand parameters and one new artefact: a pre-averaged pyramid of the tensor, about a third of its size, built once. Because the encoder is a Perceiver, its cost is linear in the token count, so this is about one and a half times E-069 per step — inside the two-times cone v2 already budgeted for itself. Per seed, E-069 ran under one GPU-hour on the North Atlantic; on the global tensor, budget two to three. Nine runs for the experiment on the next slide is on the order of twenty-five GPU-hours.</a:t>
+              <a:t>What it costs, in the same units as the earlier decks. The waist is thirteen per-location tokens each carrying all surface channels, which is fewer than the forty-two per-channel patch tokens E-069 used. The past cone is six lags of one anchor column, twenty-four ellipse dots and twenty-four ring dots, for four channel groups — about twelve hundred tokens. Argo comes as the twenty-six profile tokens cone v2 already specified. Targets are drawn as two hundred and fifty-six decoder queries per example, as now. The geometry adds about one and a half million parameters, half of them live and none of them costing compute, and one new artefact: a pre-averaged pyramid of the tensor, about a third of its size, built once. Because the encoder is a Perceiver, its cost is linear in the token count, so this is about one and a half times E-069 per step — inside the two-times cone v2 already budgeted for itself. Per seed, E-069 ran under one GPU-hour on the North Atlantic; on the global tensor, budget two to three. Nine runs for the experiment on the next slide is on the order of twenty-five GPU-hours.</a:t>
             </a:r>
             <a:endParaRPr lang="en-US" dirty="0"/>
           </a:p>
@@ -1047,7 +1047,7 @@
           <a:p>
             <a:r>
               <a:rPr lang="en-US" dirty="0"/>
-              <a:t>The experiment, written before anything runs. Three arms. The fixed hourglass with cone v2's geometry is the control and also the evaluation yardstick for every arm. The learned arm starts from the control. The primed arm starts its surface drift at the climatological current reversed, which separates two questions: can the gradient find upstream on its own, or can it only keep upstream if handed it? Everything else is held fixed — the global family 7.2 tensor, the seven-million codec, twenty thousand steps, the frozen protocol with its held-out years, three seeds per arm because the read-outs are probe-scored. Five read-outs: the forecast loss per lead against its bar; the gap between the full task and the snapshot task, which is what history buys; the correlation of the learned drift with upstream over the world ocean; the depth check at the western boundary; and the target-variance flag. The verdict rule is written now. The learned cone is adopted if it beats the control on the forecast at every lead up to three, paired at all three seeds, with the flag clean. If only the primed arm wins, the gradient cannot find upstream and geometry should be set from climatology rather than learned. If neither wins, the fixed hourglass stays and the next design is a dynamic cone — one whose drift is predicted per example from the waist — not a bigger static one.</a:t>
+              <a:t>The experiment, written before anything runs. Three arms. The fixed hourglass with cone v2's geometry is the control and also the evaluation yardstick for every arm. The learned arm starts from the control. The primed arm starts its surface drift at the climatological current reversed, which separates two questions: can the gradient find upstream on its own, or can it only keep upstream if handed it? Everything else is held fixed — the global family 7.2 tensor, the seven-million codec, twenty thousand steps, the frozen protocol with its held-out years, three seeds per arm because the read-outs are probe-scored. Five read-outs: the forecast loss per lead against its bar; the gap between the full task and the snapshot task, which is what history buys; the correlation of the learned drift with upstream over the world ocean; the depth check at the western boundary — the surface drift read from the map, the deep direction read from where the model puts its attention among the profile tokens; and the target-variance flag. The verdict rule is written now. The learned cone is adopted if it beats the control on the forecast at every lead up to three, paired at all three seeds, with the flag clean. If only the primed arm wins, the gradient cannot find upstream and geometry should be set from climatology rather than learned. If neither wins, the fixed hourglass stays and the next design is a dynamic cone — one whose drift is predicted per example from the waist — not a bigger static one.</a:t>
             </a:r>
             <a:endParaRPr lang="en-US" dirty="0"/>
           </a:p>
@@ -1135,7 +1135,7 @@
           <a:p>
             <a:r>
               <a:rPr lang="en-US" dirty="0"/>
-              <a:t>The build order, for whoever implements it. Five steps, each small enough to land with its own test before the next begins. First the geometry: the waist and the future cone as functions in the cone module, with the coverage report extended to assert the mirror identity — pure numpy, testable on a laptop. Second the task mix, as a new masking plan next to the existing one, with a test that draws ten thousand examples and finds zero targets whose channel is invisible. Third, the only step that touches the data path: the pyramid and the interpolated gather, gated on a bit-identity test — at integer positions with everything observed it must reproduce today's gather exactly. Fourth the parameter maps as a module with its bounds, the mirror, the stop-gradient and the control initialisation, checked by finite differences. Fifth the read-outs in the trainer, including exporting the learned drift maps to the app so the Cones tab can draw them. Then the three arms are three recipes on the global tensor, and E-080 is dispatched under the usual rules.</a:t>
+              <a:t>The build order, for whoever implements it. Five steps, each small enough to land with its own test before the next begins. First the geometry: the waist and the future cone as functions in the cone module, with the coverage report extended to assert the mirror identity — pure numpy, testable on a laptop. Second the task mix, as a new masking plan next to the existing one, with a test that draws ten thousand examples and finds zero targets whose channel is invisible. Third, the only step that touches the data path: the pyramid and the interpolated gather, gated on a bit-identity test — at integer positions with everything observed it must reproduce today's gather exactly. Fourth the parameter maps as a module — coarse plus residual, with its bounds, the prior, the mirror, the stop-gradient and the control initialisation — checked by finite differences. Fifth the read-outs in the trainer, including exporting the learned drift maps to the app so the Cones tab can draw them, and the attention-by-depth diagnostic at the western-boundary anchors. Then the three arms are three recipes on the global tensor, and E-080 is dispatched under the usual rules.</a:t>
             </a:r>
             <a:endParaRPr lang="en-US" dirty="0"/>
           </a:p>
@@ -1223,7 +1223,7 @@
           <a:p>
             <a:r>
               <a:rPr lang="en-US" dirty="0"/>
-              <a:t>Six choices the deck made so it could be concrete, each of them one line to change. The future cone goes to six pentads to mirror the past, where E-069 only asked for one and two. The task shares are a first guess. The parameter maps are at two degrees. The Argo depth groups split at three hundred and a thousand decibars. The v2 safety ring is kept at every lag, which is the safe and more expensive choice. And the seasonal term on the drift waits for phase two. Say the word on any of these and the spec changes; none of them affects the build order.</a:t>
+              <a:t>Two choices are settled: the maps are at one degree with the coarse-plus-residual prior, and Argo keeps its nearest-profile tokens with no ellipse. Five remain, each one line to change. The future cone goes to six pentads to mirror the past, where E-069 only asked for one and two. The task shares are a first guess. The strength of the prior on the fine map is one number, and the honest way to set it is by held-out loss on the training years rather than by hand — but the first arm may simply fix it. The v2 safety ring is kept at every lag, which is the safe and more expensive choice. And the seasonal term on the drift waits for phase two. Say the word on any of these and the spec changes; none of them affects the build order.</a:t>
             </a:r>
             <a:endParaRPr lang="en-US" dirty="0"/>
           </a:p>
@@ -2993,7 +2993,7 @@
               <a:buNone/>
             </a:pPr>
             <a:r>
-              <a:rPr lang="en-US" sz="2600" b="1" dirty="0">
+              <a:rPr lang="en-US" sz="2400" b="1" dirty="0">
                 <a:solidFill>
                   <a:srgbClr val="E6EDF3"/>
                 </a:solidFill>
@@ -3001,9 +3001,9 @@
                 <a:ea typeface="Georgia" pitchFamily="34" charset="-122"/>
                 <a:cs typeface="Georgia" pitchFamily="34" charset="-120"/>
               </a:rPr>
-              <a:t>A coarse map per channel group, interpolated to the anchor</a:t>
-            </a:r>
-            <a:endParaRPr lang="en-US" sz="2600" dirty="0"/>
+              <a:t>A 1° map per channel group, interpolated to the anchor</a:t>
+            </a:r>
+            <a:endParaRPr lang="en-US" sz="2400" dirty="0"/>
           </a:p>
         </p:txBody>
       </p:sp>
@@ -3141,17 +3141,39 @@
               <a:buChar char="•"/>
             </a:pPr>
             <a:r>
-              <a:rPr lang="en-US" sz="1250" dirty="0">
-                <a:solidFill>
-                  <a:srgbClr val="E6EDF3"/>
-                </a:solidFill>
-                <a:latin typeface="Calibri" pitchFamily="34" charset="0"/>
-                <a:ea typeface="Calibri" pitchFamily="34" charset="-122"/>
-                <a:cs typeface="Calibri" pitchFamily="34" charset="-120"/>
-              </a:rPr>
-              <a:t>A 2° grid over the globe (90 × 180 cells); the anchor's parameters are the bilinear blend of the four surrounding map cells — smooth by construction, no seams</a:t>
-            </a:r>
-            <a:endParaRPr lang="en-US" sz="1250" dirty="0"/>
+              <a:rPr lang="en-US" sz="1150" dirty="0">
+                <a:solidFill>
+                  <a:srgbClr val="E6EDF3"/>
+                </a:solidFill>
+                <a:latin typeface="Calibri" pitchFamily="34" charset="0"/>
+                <a:ea typeface="Calibri" pitchFamily="34" charset="-122"/>
+                <a:cs typeface="Calibri" pitchFamily="34" charset="-120"/>
+              </a:rPr>
+              <a:t>A </a:t>
+            </a:r>
+            <a:r>
+              <a:rPr lang="en-US" sz="1150" b="1" dirty="0">
+                <a:solidFill>
+                  <a:srgbClr val="4493F8"/>
+                </a:solidFill>
+                <a:latin typeface="Calibri" pitchFamily="34" charset="0"/>
+                <a:ea typeface="Calibri" pitchFamily="34" charset="-122"/>
+                <a:cs typeface="Calibri" pitchFamily="34" charset="-120"/>
+              </a:rPr>
+              <a:t>1° grid</a:t>
+            </a:r>
+            <a:r>
+              <a:rPr lang="en-US" sz="1150" dirty="0">
+                <a:solidFill>
+                  <a:srgbClr val="E6EDF3"/>
+                </a:solidFill>
+                <a:latin typeface="Calibri" pitchFamily="34" charset="0"/>
+                <a:ea typeface="Calibri" pitchFamily="34" charset="-122"/>
+                <a:cs typeface="Calibri" pitchFamily="34" charset="-120"/>
+              </a:rPr>
+              <a:t> over the globe (180 × 360 = 64,800 cells); the anchor's parameters are the bilinear blend of the four surrounding map cells — smooth by construction, no seams</a:t>
+            </a:r>
+            <a:endParaRPr lang="en-US" sz="1150" dirty="0"/>
           </a:p>
           <a:p>
             <a:pPr marL="203200" indent="-203200">
@@ -3162,7 +3184,7 @@
               <a:buChar char="•"/>
             </a:pPr>
             <a:r>
-              <a:rPr lang="en-US" sz="1250" b="1" dirty="0">
+              <a:rPr lang="en-US" sz="1150" b="1" dirty="0">
                 <a:solidFill>
                   <a:srgbClr val="4493F8"/>
                 </a:solidFill>
@@ -3170,20 +3192,20 @@
                 <a:ea typeface="Calibri" pitchFamily="34" charset="-122"/>
                 <a:cs typeface="Calibri" pitchFamily="34" charset="-120"/>
               </a:rPr>
-              <a:t>One map per channel group,</a:t>
-            </a:r>
-            <a:r>
-              <a:rPr lang="en-US" sz="1250" dirty="0">
-                <a:solidFill>
-                  <a:srgbClr val="E6EDF3"/>
-                </a:solidFill>
-                <a:latin typeface="Calibri" pitchFamily="34" charset="0"/>
-                <a:ea typeface="Calibri" pitchFamily="34" charset="-122"/>
-                <a:cs typeface="Calibri" pitchFamily="34" charset="-120"/>
-              </a:rPr>
-              <a:t> because the source of a signal depends on what moves it</a:t>
-            </a:r>
-            <a:endParaRPr lang="en-US" sz="1250" dirty="0"/>
+              <a:t>1° because</a:t>
+            </a:r>
+            <a:r>
+              <a:rPr lang="en-US" sz="1150" dirty="0">
+                <a:solidFill>
+                  <a:srgbClr val="E6EDF3"/>
+                </a:solidFill>
+                <a:latin typeface="Calibri" pitchFamily="34" charset="0"/>
+                <a:ea typeface="Calibri" pitchFamily="34" charset="-122"/>
+                <a:cs typeface="Calibri" pitchFamily="34" charset="-120"/>
+              </a:rPr>
+              <a:t> the currents that carry the overturning are ~100 km wide (the Florida Current sits in an 80 km strait); a 10° cell would average the Gulf Stream with its recirculation and learn a drift near zero</a:t>
+            </a:r>
+            <a:endParaRPr lang="en-US" sz="1150" dirty="0"/>
           </a:p>
           <a:p>
             <a:pPr marL="203200" indent="-203200">
@@ -3194,7 +3216,7 @@
               <a:buChar char="•"/>
             </a:pPr>
             <a:r>
-              <a:rPr lang="en-US" sz="1250" b="1" dirty="0">
+              <a:rPr lang="en-US" sz="1150" b="1" dirty="0">
                 <a:solidFill>
                   <a:srgbClr val="4493F8"/>
                 </a:solidFill>
@@ -3202,86 +3224,20 @@
                 <a:ea typeface="Calibri" pitchFamily="34" charset="-122"/>
                 <a:cs typeface="Calibri" pitchFamily="34" charset="-120"/>
               </a:rPr>
-              <a:t>Optional, phase 2:</a:t>
-            </a:r>
-            <a:r>
-              <a:rPr lang="en-US" sz="1250" dirty="0">
-                <a:solidFill>
-                  <a:srgbClr val="E6EDF3"/>
-                </a:solidFill>
-                <a:latin typeface="Calibri" pitchFamily="34" charset="0"/>
-                <a:ea typeface="Calibri" pitchFamily="34" charset="-122"/>
-                <a:cs typeface="Calibri" pitchFamily="34" charset="-120"/>
-              </a:rPr>
-              <a:t> a first-harmonic seasonal term on the drift, d(τ) = d</a:t>
-            </a:r>
-            <a:r>
-              <a:rPr lang="en-US" sz="1250" baseline="-40000" dirty="0">
-                <a:solidFill>
-                  <a:srgbClr val="E6EDF3"/>
-                </a:solidFill>
-                <a:latin typeface="Calibri" pitchFamily="34" charset="0"/>
-                <a:ea typeface="Calibri" pitchFamily="34" charset="-122"/>
-                <a:cs typeface="Calibri" pitchFamily="34" charset="-120"/>
-              </a:rPr>
-              <a:t>0</a:t>
-            </a:r>
-            <a:r>
-              <a:rPr lang="en-US" sz="1250" dirty="0">
-                <a:solidFill>
-                  <a:srgbClr val="E6EDF3"/>
-                </a:solidFill>
-                <a:latin typeface="Calibri" pitchFamily="34" charset="0"/>
-                <a:ea typeface="Calibri" pitchFamily="34" charset="-122"/>
-                <a:cs typeface="Calibri" pitchFamily="34" charset="-120"/>
-              </a:rPr>
-              <a:t> + d</a:t>
-            </a:r>
-            <a:r>
-              <a:rPr lang="en-US" sz="1250" baseline="-40000" dirty="0">
-                <a:solidFill>
-                  <a:srgbClr val="E6EDF3"/>
-                </a:solidFill>
-                <a:latin typeface="Calibri" pitchFamily="34" charset="0"/>
-                <a:ea typeface="Calibri" pitchFamily="34" charset="-122"/>
-                <a:cs typeface="Calibri" pitchFamily="34" charset="-120"/>
-              </a:rPr>
-              <a:t>1</a:t>
-            </a:r>
-            <a:r>
-              <a:rPr lang="en-US" sz="1250" dirty="0">
-                <a:solidFill>
-                  <a:srgbClr val="E6EDF3"/>
-                </a:solidFill>
-                <a:latin typeface="Calibri" pitchFamily="34" charset="0"/>
-                <a:ea typeface="Calibri" pitchFamily="34" charset="-122"/>
-                <a:cs typeface="Calibri" pitchFamily="34" charset="-120"/>
-              </a:rPr>
-              <a:t> cos τ + d</a:t>
-            </a:r>
-            <a:r>
-              <a:rPr lang="en-US" sz="1250" baseline="-40000" dirty="0">
-                <a:solidFill>
-                  <a:srgbClr val="E6EDF3"/>
-                </a:solidFill>
-                <a:latin typeface="Calibri" pitchFamily="34" charset="0"/>
-                <a:ea typeface="Calibri" pitchFamily="34" charset="-122"/>
-                <a:cs typeface="Calibri" pitchFamily="34" charset="-120"/>
-              </a:rPr>
-              <a:t>2</a:t>
-            </a:r>
-            <a:r>
-              <a:rPr lang="en-US" sz="1250" dirty="0">
-                <a:solidFill>
-                  <a:srgbClr val="E6EDF3"/>
-                </a:solidFill>
-                <a:latin typeface="Calibri" pitchFamily="34" charset="0"/>
-                <a:ea typeface="Calibri" pitchFamily="34" charset="-122"/>
-                <a:cs typeface="Calibri" pitchFamily="34" charset="-120"/>
-              </a:rPr>
-              <a:t> sin τ — the Somali Current reverses with the monsoon</a:t>
-            </a:r>
-            <a:endParaRPr lang="en-US" sz="1250" dirty="0"/>
+              <a:t>Hierarchical prior:</a:t>
+            </a:r>
+            <a:r>
+              <a:rPr lang="en-US" sz="1150" dirty="0">
+                <a:solidFill>
+                  <a:srgbClr val="E6EDF3"/>
+                </a:solidFill>
+                <a:latin typeface="Calibri" pitchFamily="34" charset="0"/>
+                <a:ea typeface="Calibri" pitchFamily="34" charset="-122"/>
+                <a:cs typeface="Calibri" pitchFamily="34" charset="-120"/>
+              </a:rPr>
+              <a:t> each map is a coarse 10° map plus a 1° residual, the residual under L2 shrinkage and a Laplacian smoothness penalty — a data-poor cell (ice edge, coast) inherits its neighbourhood's arrow instead of fitting noise. Each 1° cell still sees 16 anchors × 3,142 pentads ≈ 50 k anchor-pentads for seven numbers</a:t>
+            </a:r>
+            <a:endParaRPr lang="en-US" sz="1150" dirty="0"/>
           </a:p>
           <a:p>
             <a:pPr marL="203200" indent="-203200">
@@ -3292,7 +3248,7 @@
               <a:buChar char="•"/>
             </a:pPr>
             <a:r>
-              <a:rPr lang="en-US" sz="1250" b="1" dirty="0">
+              <a:rPr lang="en-US" sz="1150" b="1" dirty="0">
                 <a:solidFill>
                   <a:srgbClr val="4493F8"/>
                 </a:solidFill>
@@ -3300,20 +3256,118 @@
                 <a:ea typeface="Calibri" pitchFamily="34" charset="-122"/>
                 <a:cs typeface="Calibri" pitchFamily="34" charset="-120"/>
               </a:rPr>
-              <a:t>Why per depth:</a:t>
-            </a:r>
-            <a:r>
-              <a:rPr lang="en-US" sz="1250" dirty="0">
-                <a:solidFill>
-                  <a:srgbClr val="E6EDF3"/>
-                </a:solidFill>
-                <a:latin typeface="Calibri" pitchFamily="34" charset="0"/>
-                <a:ea typeface="Calibri" pitchFamily="34" charset="-122"/>
-                <a:cs typeface="Calibri" pitchFamily="34" charset="-120"/>
-              </a:rPr>
-              <a:t> at the RAPID line the upper limb flows north and the Deep Western Boundary Current flows south — the same anchor should point its surface cone south and its deep cone north</a:t>
-            </a:r>
-            <a:endParaRPr lang="en-US" sz="1250" dirty="0"/>
+              <a:t>No Argo ellipse.</a:t>
+            </a:r>
+            <a:r>
+              <a:rPr lang="en-US" sz="1150" dirty="0">
+                <a:solidFill>
+                  <a:srgbClr val="E6EDF3"/>
+                </a:solidFill>
+                <a:latin typeface="Calibri" pitchFamily="34" charset="0"/>
+                <a:ea typeface="Calibri" pitchFamily="34" charset="-122"/>
+                <a:cs typeface="Calibri" pitchFamily="34" charset="-120"/>
+              </a:rPr>
+              <a:t> The Argo channels are the k nearest profile tokens (E-071 §3, E-076) — placed where floats were, each carrying its own offset, age and depth. There is no elliptic shape to learn; the search radius stays as specified there. Depth-dependent sourcing (at the RAPID line the upper limb flows north, the Deep Western Boundary Current south) is left to attention over those tokens, which see depth and offset together</a:t>
+            </a:r>
+            <a:endParaRPr lang="en-US" sz="1150" dirty="0"/>
+          </a:p>
+          <a:p>
+            <a:pPr marL="203200" indent="-203200">
+              <a:spcAft>
+                <a:spcPts val="700"/>
+              </a:spcAft>
+              <a:buSzPct val="100000"/>
+              <a:buChar char="•"/>
+            </a:pPr>
+            <a:r>
+              <a:rPr lang="en-US" sz="1150" b="1" dirty="0">
+                <a:solidFill>
+                  <a:srgbClr val="4493F8"/>
+                </a:solidFill>
+                <a:latin typeface="Calibri" pitchFamily="34" charset="0"/>
+                <a:ea typeface="Calibri" pitchFamily="34" charset="-122"/>
+                <a:cs typeface="Calibri" pitchFamily="34" charset="-120"/>
+              </a:rPr>
+              <a:t>Optional, phase 2:</a:t>
+            </a:r>
+            <a:r>
+              <a:rPr lang="en-US" sz="1150" dirty="0">
+                <a:solidFill>
+                  <a:srgbClr val="E6EDF3"/>
+                </a:solidFill>
+                <a:latin typeface="Calibri" pitchFamily="34" charset="0"/>
+                <a:ea typeface="Calibri" pitchFamily="34" charset="-122"/>
+                <a:cs typeface="Calibri" pitchFamily="34" charset="-120"/>
+              </a:rPr>
+              <a:t> a first-harmonic seasonal term on the drift, d(τ) = d</a:t>
+            </a:r>
+            <a:r>
+              <a:rPr lang="en-US" sz="1150" baseline="-40000" dirty="0">
+                <a:solidFill>
+                  <a:srgbClr val="E6EDF3"/>
+                </a:solidFill>
+                <a:latin typeface="Calibri" pitchFamily="34" charset="0"/>
+                <a:ea typeface="Calibri" pitchFamily="34" charset="-122"/>
+                <a:cs typeface="Calibri" pitchFamily="34" charset="-120"/>
+              </a:rPr>
+              <a:t>0</a:t>
+            </a:r>
+            <a:r>
+              <a:rPr lang="en-US" sz="1150" dirty="0">
+                <a:solidFill>
+                  <a:srgbClr val="E6EDF3"/>
+                </a:solidFill>
+                <a:latin typeface="Calibri" pitchFamily="34" charset="0"/>
+                <a:ea typeface="Calibri" pitchFamily="34" charset="-122"/>
+                <a:cs typeface="Calibri" pitchFamily="34" charset="-120"/>
+              </a:rPr>
+              <a:t> + d</a:t>
+            </a:r>
+            <a:r>
+              <a:rPr lang="en-US" sz="1150" baseline="-40000" dirty="0">
+                <a:solidFill>
+                  <a:srgbClr val="E6EDF3"/>
+                </a:solidFill>
+                <a:latin typeface="Calibri" pitchFamily="34" charset="0"/>
+                <a:ea typeface="Calibri" pitchFamily="34" charset="-122"/>
+                <a:cs typeface="Calibri" pitchFamily="34" charset="-120"/>
+              </a:rPr>
+              <a:t>1</a:t>
+            </a:r>
+            <a:r>
+              <a:rPr lang="en-US" sz="1150" dirty="0">
+                <a:solidFill>
+                  <a:srgbClr val="E6EDF3"/>
+                </a:solidFill>
+                <a:latin typeface="Calibri" pitchFamily="34" charset="0"/>
+                <a:ea typeface="Calibri" pitchFamily="34" charset="-122"/>
+                <a:cs typeface="Calibri" pitchFamily="34" charset="-120"/>
+              </a:rPr>
+              <a:t> cos τ + d</a:t>
+            </a:r>
+            <a:r>
+              <a:rPr lang="en-US" sz="1150" baseline="-40000" dirty="0">
+                <a:solidFill>
+                  <a:srgbClr val="E6EDF3"/>
+                </a:solidFill>
+                <a:latin typeface="Calibri" pitchFamily="34" charset="0"/>
+                <a:ea typeface="Calibri" pitchFamily="34" charset="-122"/>
+                <a:cs typeface="Calibri" pitchFamily="34" charset="-120"/>
+              </a:rPr>
+              <a:t>2</a:t>
+            </a:r>
+            <a:r>
+              <a:rPr lang="en-US" sz="1150" dirty="0">
+                <a:solidFill>
+                  <a:srgbClr val="E6EDF3"/>
+                </a:solidFill>
+                <a:latin typeface="Calibri" pitchFamily="34" charset="0"/>
+                <a:ea typeface="Calibri" pitchFamily="34" charset="-122"/>
+                <a:cs typeface="Calibri" pitchFamily="34" charset="-120"/>
+              </a:rPr>
+              <a:t> sin τ — the Somali Current reverses with the monsoon</a:t>
+            </a:r>
+            <a:endParaRPr lang="en-US" sz="1150" dirty="0"/>
           </a:p>
         </p:txBody>
       </p:sp>
@@ -3326,11 +3380,11 @@
         <p:spPr>
           <a:xfrm>
             <a:off x="7635240" y="1463040"/>
-            <a:ext cx="4005072" cy="2880360"/>
+            <a:ext cx="4005072" cy="1783080"/>
           </a:xfrm>
           <a:prstGeom prst="roundRect">
             <a:avLst>
-              <a:gd name="adj" fmla="val 1905"/>
+              <a:gd name="adj" fmla="val 3077"/>
             </a:avLst>
           </a:prstGeom>
           <a:solidFill>
@@ -3352,7 +3406,7 @@
         </p:nvSpPr>
         <p:spPr>
           <a:xfrm>
-            <a:off x="7891272" y="1645920"/>
+            <a:off x="7891272" y="1627632"/>
             <a:ext cx="3493008" cy="256032"/>
           </a:xfrm>
           <a:prstGeom prst="rect">
@@ -3377,7 +3431,7 @@
                 <a:ea typeface="Calibri" pitchFamily="34" charset="-122"/>
                 <a:cs typeface="Calibri" pitchFamily="34" charset="-120"/>
               </a:rPr>
-              <a:t>the six channel groups</a:t>
+              <a:t>one map per channel group</a:t>
             </a:r>
             <a:endParaRPr lang="en-US" sz="1250" dirty="0"/>
           </a:p>
@@ -3391,8 +3445,8 @@
         </p:nvSpPr>
         <p:spPr>
           <a:xfrm>
-            <a:off x="7891272" y="1975104"/>
-            <a:ext cx="3493008" cy="2194560"/>
+            <a:off x="7891272" y="1956816"/>
+            <a:ext cx="3493008" cy="1143000"/>
           </a:xfrm>
           <a:prstGeom prst="rect">
             <a:avLst/>
@@ -3406,7 +3460,7 @@
           <a:p>
             <a:pPr indent="0" marL="0">
               <a:spcAft>
-                <a:spcPts val="500"/>
+                <a:spcPts val="600"/>
               </a:spcAft>
               <a:buNone/>
             </a:pPr>
@@ -3437,7 +3491,7 @@
           <a:p>
             <a:pPr indent="0" marL="0">
               <a:spcAft>
-                <a:spcPts val="500"/>
+                <a:spcPts val="600"/>
               </a:spcAft>
               <a:buNone/>
             </a:pPr>
@@ -3450,7 +3504,7 @@
                 <a:ea typeface="Calibri" pitchFamily="34" charset="-122"/>
                 <a:cs typeface="Calibri" pitchFamily="34" charset="-120"/>
               </a:rPr>
-              <a:t>Argo upper</a:t>
+              <a:t>atmosphere</a:t>
             </a:r>
             <a:r>
               <a:rPr lang="en-US" sz="1050" dirty="0">
@@ -3461,107 +3515,14 @@
                 <a:ea typeface="Calibri" pitchFamily="34" charset="-122"/>
                 <a:cs typeface="Calibri" pitchFamily="34" charset="-120"/>
               </a:rPr>
-              <a:t> — ≤ 300 dbar</a:t>
+              <a:t> — drift only at lags 0–1</a:t>
             </a:r>
             <a:endParaRPr lang="en-US" sz="1050" dirty="0"/>
           </a:p>
           <a:p>
             <a:pPr indent="0" marL="0">
               <a:spcAft>
-                <a:spcPts val="500"/>
-              </a:spcAft>
-              <a:buNone/>
-            </a:pPr>
-            <a:r>
-              <a:rPr lang="en-US" sz="1050" b="1" dirty="0">
-                <a:solidFill>
-                  <a:srgbClr val="4493F8"/>
-                </a:solidFill>
-                <a:latin typeface="Calibri" pitchFamily="34" charset="0"/>
-                <a:ea typeface="Calibri" pitchFamily="34" charset="-122"/>
-                <a:cs typeface="Calibri" pitchFamily="34" charset="-120"/>
-              </a:rPr>
-              <a:t>Argo mid</a:t>
-            </a:r>
-            <a:r>
-              <a:rPr lang="en-US" sz="1050" dirty="0">
-                <a:solidFill>
-                  <a:srgbClr val="E6EDF3"/>
-                </a:solidFill>
-                <a:latin typeface="Calibri" pitchFamily="34" charset="0"/>
-                <a:ea typeface="Calibri" pitchFamily="34" charset="-122"/>
-                <a:cs typeface="Calibri" pitchFamily="34" charset="-120"/>
-              </a:rPr>
-              <a:t> — 300–1000 dbar</a:t>
-            </a:r>
-            <a:endParaRPr lang="en-US" sz="1050" dirty="0"/>
-          </a:p>
-          <a:p>
-            <a:pPr indent="0" marL="0">
-              <a:spcAft>
-                <a:spcPts val="500"/>
-              </a:spcAft>
-              <a:buNone/>
-            </a:pPr>
-            <a:r>
-              <a:rPr lang="en-US" sz="1050" b="1" dirty="0">
-                <a:solidFill>
-                  <a:srgbClr val="4493F8"/>
-                </a:solidFill>
-                <a:latin typeface="Calibri" pitchFamily="34" charset="0"/>
-                <a:ea typeface="Calibri" pitchFamily="34" charset="-122"/>
-                <a:cs typeface="Calibri" pitchFamily="34" charset="-120"/>
-              </a:rPr>
-              <a:t>Argo deep</a:t>
-            </a:r>
-            <a:r>
-              <a:rPr lang="en-US" sz="1050" dirty="0">
-                <a:solidFill>
-                  <a:srgbClr val="E6EDF3"/>
-                </a:solidFill>
-                <a:latin typeface="Calibri" pitchFamily="34" charset="0"/>
-                <a:ea typeface="Calibri" pitchFamily="34" charset="-122"/>
-                <a:cs typeface="Calibri" pitchFamily="34" charset="-120"/>
-              </a:rPr>
-              <a:t> — &gt; 1000 dbar</a:t>
-            </a:r>
-            <a:endParaRPr lang="en-US" sz="1050" dirty="0"/>
-          </a:p>
-          <a:p>
-            <a:pPr indent="0" marL="0">
-              <a:spcAft>
-                <a:spcPts val="500"/>
-              </a:spcAft>
-              <a:buNone/>
-            </a:pPr>
-            <a:r>
-              <a:rPr lang="en-US" sz="1050" b="1" dirty="0">
-                <a:solidFill>
-                  <a:srgbClr val="4493F8"/>
-                </a:solidFill>
-                <a:latin typeface="Calibri" pitchFamily="34" charset="0"/>
-                <a:ea typeface="Calibri" pitchFamily="34" charset="-122"/>
-                <a:cs typeface="Calibri" pitchFamily="34" charset="-120"/>
-              </a:rPr>
-              <a:t>atmosphere</a:t>
-            </a:r>
-            <a:r>
-              <a:rPr lang="en-US" sz="1050" dirty="0">
-                <a:solidFill>
-                  <a:srgbClr val="E6EDF3"/>
-                </a:solidFill>
-                <a:latin typeface="Calibri" pitchFamily="34" charset="0"/>
-                <a:ea typeface="Calibri" pitchFamily="34" charset="-122"/>
-                <a:cs typeface="Calibri" pitchFamily="34" charset="-120"/>
-              </a:rPr>
-              <a:t> — drift only at lags 0–1</a:t>
-            </a:r>
-            <a:endParaRPr lang="en-US" sz="1050" dirty="0"/>
-          </a:p>
-          <a:p>
-            <a:pPr indent="0" marL="0">
-              <a:spcAft>
-                <a:spcPts val="500"/>
+                <a:spcPts val="600"/>
               </a:spcAft>
               <a:buNone/>
             </a:pPr>
@@ -3599,12 +3560,12 @@
         </p:nvSpPr>
         <p:spPr>
           <a:xfrm>
-            <a:off x="7635240" y="4526280"/>
-            <a:ext cx="4005072" cy="1143000"/>
+            <a:off x="7635240" y="3429000"/>
+            <a:ext cx="4005072" cy="2240280"/>
           </a:xfrm>
           <a:prstGeom prst="roundRect">
             <a:avLst>
-              <a:gd name="adj" fmla="val 4800"/>
+              <a:gd name="adj" fmla="val 2449"/>
             </a:avLst>
           </a:prstGeom>
           <a:solidFill>
@@ -3626,8 +3587,8 @@
         </p:nvSpPr>
         <p:spPr>
           <a:xfrm>
-            <a:off x="7872984" y="4672584"/>
-            <a:ext cx="3529584" cy="850392"/>
+            <a:off x="7872984" y="3575304"/>
+            <a:ext cx="3529584" cy="1947672"/>
           </a:xfrm>
           <a:prstGeom prst="rect">
             <a:avLst/>
@@ -3654,7 +3615,7 @@
                 <a:ea typeface="Georgia" pitchFamily="34" charset="-122"/>
                 <a:cs typeface="Georgia" pitchFamily="34" charset="-120"/>
               </a:rPr>
-              <a:t>≈ 0.7 M</a:t>
+              <a:t>≈ 1.4 M</a:t>
             </a:r>
             <a:endParaRPr lang="en-US" sz="3000" dirty="0"/>
           </a:p>
@@ -3674,7 +3635,7 @@
                 <a:ea typeface="Calibri" pitchFamily="34" charset="-122"/>
                 <a:cs typeface="Calibri" pitchFamily="34" charset="-120"/>
               </a:rPr>
-              <a:t>geometry parameters</a:t>
+              <a:t>geometry parameters, nominal</a:t>
             </a:r>
             <a:endParaRPr lang="en-US" sz="3000" dirty="0"/>
           </a:p>
@@ -3691,7 +3652,7 @@
                 <a:ea typeface="Calibri" pitchFamily="34" charset="-122"/>
                 <a:cs typeface="Calibri" pitchFamily="34" charset="-120"/>
               </a:rPr>
-              <a:t>16,200 cells × 6 groups × 7 numbers — a tenth of the 7 M codec</a:t>
+              <a:t>64,800 cells × 3 groups × 7 numbers, about half of it live (ocean maps over ocean, land maps over land) — cheap, and no compute</a:t>
             </a:r>
             <a:endParaRPr lang="en-US" sz="3000" dirty="0"/>
           </a:p>
@@ -3894,7 +3855,7 @@
         <p:spPr>
           <a:xfrm>
             <a:off x="548640" y="1463040"/>
-            <a:ext cx="3557016" cy="2148840"/>
+            <a:ext cx="2621585" cy="2148840"/>
           </a:xfrm>
           <a:prstGeom prst="roundRect">
             <a:avLst>
@@ -3921,7 +3882,7 @@
         <p:spPr>
           <a:xfrm>
             <a:off x="786384" y="1609344"/>
-            <a:ext cx="3081528" cy="1856232"/>
+            <a:ext cx="2146097" cy="1856232"/>
           </a:xfrm>
           <a:prstGeom prst="rect">
             <a:avLst/>
@@ -3957,7 +3918,7 @@
               <a:buNone/>
             </a:pPr>
             <a:r>
-              <a:rPr lang="en-US" sz="1150" dirty="0">
+              <a:rPr lang="en-US" sz="1050" dirty="0">
                 <a:solidFill>
                   <a:srgbClr val="E6EDF3"/>
                 </a:solidFill>
@@ -3968,7 +3929,7 @@
               <a:t>|</a:t>
             </a:r>
             <a:r>
-              <a:rPr lang="en-US" sz="1150" b="1" dirty="0">
+              <a:rPr lang="en-US" sz="1050" b="1" dirty="0">
                 <a:solidFill>
                   <a:srgbClr val="4493F8"/>
                 </a:solidFill>
@@ -3979,7 +3940,7 @@
               <a:t>d</a:t>
             </a:r>
             <a:r>
-              <a:rPr lang="en-US" sz="1150" dirty="0">
+              <a:rPr lang="en-US" sz="1050" dirty="0">
                 <a:solidFill>
                   <a:srgbClr val="E6EDF3"/>
                 </a:solidFill>
@@ -4001,8 +3962,8 @@
         </p:nvSpPr>
         <p:spPr>
           <a:xfrm>
-            <a:off x="4315968" y="1463040"/>
-            <a:ext cx="3557016" cy="2148840"/>
+            <a:off x="3371393" y="1463040"/>
+            <a:ext cx="2621585" cy="2148840"/>
           </a:xfrm>
           <a:prstGeom prst="roundRect">
             <a:avLst>
@@ -4028,8 +3989,8 @@
         </p:nvSpPr>
         <p:spPr>
           <a:xfrm>
-            <a:off x="4553712" y="1609344"/>
-            <a:ext cx="3081528" cy="1856232"/>
+            <a:off x="3609137" y="1609344"/>
+            <a:ext cx="2146097" cy="1856232"/>
           </a:xfrm>
           <a:prstGeom prst="rect">
             <a:avLst/>
@@ -4065,7 +4026,7 @@
               <a:buNone/>
             </a:pPr>
             <a:r>
-              <a:rPr lang="en-US" sz="1150" dirty="0">
+              <a:rPr lang="en-US" sz="1050" dirty="0">
                 <a:solidFill>
                   <a:srgbClr val="E6EDF3"/>
                 </a:solidFill>
@@ -4076,7 +4037,7 @@
               <a:t>a</a:t>
             </a:r>
             <a:r>
-              <a:rPr lang="en-US" sz="1150" baseline="-40000" dirty="0">
+              <a:rPr lang="en-US" sz="1050" baseline="-40000" dirty="0">
                 <a:solidFill>
                   <a:srgbClr val="E6EDF3"/>
                 </a:solidFill>
@@ -4087,7 +4048,7 @@
               <a:t>0</a:t>
             </a:r>
             <a:r>
-              <a:rPr lang="en-US" sz="1150" dirty="0">
+              <a:rPr lang="en-US" sz="1050" dirty="0">
                 <a:solidFill>
                   <a:srgbClr val="E6EDF3"/>
                 </a:solidFill>
@@ -4098,7 +4059,7 @@
               <a:t>, b</a:t>
             </a:r>
             <a:r>
-              <a:rPr lang="en-US" sz="1150" baseline="-40000" dirty="0">
+              <a:rPr lang="en-US" sz="1050" baseline="-40000" dirty="0">
                 <a:solidFill>
                   <a:srgbClr val="E6EDF3"/>
                 </a:solidFill>
@@ -4109,7 +4070,7 @@
               <a:t>0</a:t>
             </a:r>
             <a:r>
-              <a:rPr lang="en-US" sz="1150" dirty="0">
+              <a:rPr lang="en-US" sz="1050" dirty="0">
                 <a:solidFill>
                   <a:srgbClr val="E6EDF3"/>
                 </a:solidFill>
@@ -4120,7 +4081,7 @@
               <a:t> ≥ one cell (28 km); s</a:t>
             </a:r>
             <a:r>
-              <a:rPr lang="en-US" sz="1150" baseline="-40000" dirty="0">
+              <a:rPr lang="en-US" sz="1050" baseline="-40000" dirty="0">
                 <a:solidFill>
                   <a:srgbClr val="E6EDF3"/>
                 </a:solidFill>
@@ -4131,7 +4092,7 @@
               <a:t>a</a:t>
             </a:r>
             <a:r>
-              <a:rPr lang="en-US" sz="1150" dirty="0">
+              <a:rPr lang="en-US" sz="1050" dirty="0">
                 <a:solidFill>
                   <a:srgbClr val="E6EDF3"/>
                 </a:solidFill>
@@ -4142,7 +4103,7 @@
               <a:t>, s</a:t>
             </a:r>
             <a:r>
-              <a:rPr lang="en-US" sz="1150" baseline="-40000" dirty="0">
+              <a:rPr lang="en-US" sz="1050" baseline="-40000" dirty="0">
                 <a:solidFill>
                   <a:srgbClr val="E6EDF3"/>
                 </a:solidFill>
@@ -4153,7 +4114,7 @@
               <a:t>b</a:t>
             </a:r>
             <a:r>
-              <a:rPr lang="en-US" sz="1150" dirty="0">
+              <a:rPr lang="en-US" sz="1050" dirty="0">
                 <a:solidFill>
                   <a:srgbClr val="E6EDF3"/>
                 </a:solidFill>
@@ -4164,7 +4125,7 @@
               <a:t> ≥ 0; a</a:t>
             </a:r>
             <a:r>
-              <a:rPr lang="en-US" sz="1150" baseline="-40000" dirty="0">
+              <a:rPr lang="en-US" sz="1050" baseline="-40000" dirty="0">
                 <a:solidFill>
                   <a:srgbClr val="E6EDF3"/>
                 </a:solidFill>
@@ -4175,7 +4136,7 @@
               <a:t>0</a:t>
             </a:r>
             <a:r>
-              <a:rPr lang="en-US" sz="1150" dirty="0">
+              <a:rPr lang="en-US" sz="1050" dirty="0">
                 <a:solidFill>
                   <a:srgbClr val="E6EDF3"/>
                 </a:solidFill>
@@ -4186,7 +4147,7 @@
               <a:t> + 6 s</a:t>
             </a:r>
             <a:r>
-              <a:rPr lang="en-US" sz="1150" baseline="-40000" dirty="0">
+              <a:rPr lang="en-US" sz="1050" baseline="-40000" dirty="0">
                 <a:solidFill>
                   <a:srgbClr val="E6EDF3"/>
                 </a:solidFill>
@@ -4197,7 +4158,7 @@
               <a:t>a</a:t>
             </a:r>
             <a:r>
-              <a:rPr lang="en-US" sz="1150" dirty="0">
+              <a:rPr lang="en-US" sz="1050" dirty="0">
                 <a:solidFill>
                   <a:srgbClr val="E6EDF3"/>
                 </a:solidFill>
@@ -4219,8 +4180,8 @@
         </p:nvSpPr>
         <p:spPr>
           <a:xfrm>
-            <a:off x="8083296" y="1463040"/>
-            <a:ext cx="3557016" cy="2148840"/>
+            <a:off x="6194146" y="1463040"/>
+            <a:ext cx="2621585" cy="2148840"/>
           </a:xfrm>
           <a:prstGeom prst="roundRect">
             <a:avLst>
@@ -4246,8 +4207,8 @@
         </p:nvSpPr>
         <p:spPr>
           <a:xfrm>
-            <a:off x="8321040" y="1609344"/>
-            <a:ext cx="3081528" cy="1856232"/>
+            <a:off x="6431890" y="1609344"/>
+            <a:ext cx="2146097" cy="1856232"/>
           </a:xfrm>
           <a:prstGeom prst="rect">
             <a:avLst/>
@@ -4274,7 +4235,7 @@
                 <a:ea typeface="Calibri" pitchFamily="34" charset="-122"/>
                 <a:cs typeface="Calibri" pitchFamily="34" charset="-120"/>
               </a:rPr>
-              <a:t>Mirror tie, by default</a:t>
+              <a:t>Prior</a:t>
             </a:r>
             <a:endParaRPr lang="en-US" sz="1250" dirty="0"/>
           </a:p>
@@ -4283,15 +4244,15 @@
               <a:buNone/>
             </a:pPr>
             <a:r>
-              <a:rPr lang="en-US" sz="1150" dirty="0">
-                <a:solidFill>
-                  <a:srgbClr val="E6EDF3"/>
-                </a:solidFill>
-                <a:latin typeface="Calibri" pitchFamily="34" charset="0"/>
-                <a:ea typeface="Calibri" pitchFamily="34" charset="-122"/>
-                <a:cs typeface="Calibri" pitchFamily="34" charset="-120"/>
-              </a:rPr>
-              <a:t>The future cone shares the seven numbers (reflected); an untied arm is the ablation, not the design</a:t>
+              <a:rPr lang="en-US" sz="1050" dirty="0">
+                <a:solidFill>
+                  <a:srgbClr val="E6EDF3"/>
+                </a:solidFill>
+                <a:latin typeface="Calibri" pitchFamily="34" charset="0"/>
+                <a:ea typeface="Calibri" pitchFamily="34" charset="-122"/>
+                <a:cs typeface="Calibri" pitchFamily="34" charset="-120"/>
+              </a:rPr>
+              <a:t>Coarse 10° + 1° residual, L2 shrinkage and Laplacian smoothness on the residual (slide 10) — one weight, recorded in the run's metrics</a:t>
             </a:r>
             <a:endParaRPr lang="en-US" sz="1250" dirty="0"/>
           </a:p>
@@ -4305,8 +4266,8 @@
         </p:nvSpPr>
         <p:spPr>
           <a:xfrm>
-            <a:off x="548640" y="3840480"/>
-            <a:ext cx="3557016" cy="2148840"/>
+            <a:off x="9016898" y="1463040"/>
+            <a:ext cx="2621585" cy="2148840"/>
           </a:xfrm>
           <a:prstGeom prst="roundRect">
             <a:avLst>
@@ -4332,8 +4293,8 @@
         </p:nvSpPr>
         <p:spPr>
           <a:xfrm>
-            <a:off x="786384" y="3986784"/>
-            <a:ext cx="3081528" cy="1856232"/>
+            <a:off x="9254642" y="1609344"/>
+            <a:ext cx="2146097" cy="1856232"/>
           </a:xfrm>
           <a:prstGeom prst="rect">
             <a:avLst/>
@@ -4360,7 +4321,7 @@
                 <a:ea typeface="Calibri" pitchFamily="34" charset="-122"/>
                 <a:cs typeface="Calibri" pitchFamily="34" charset="-120"/>
               </a:rPr>
-              <a:t>Stop-gradient on the target side</a:t>
+              <a:t>Mirror tie, by default</a:t>
             </a:r>
             <a:endParaRPr lang="en-US" sz="1250" dirty="0"/>
           </a:p>
@@ -4369,37 +4330,15 @@
               <a:buNone/>
             </a:pPr>
             <a:r>
-              <a:rPr lang="en-US" sz="1150" dirty="0">
-                <a:solidFill>
-                  <a:srgbClr val="E6EDF3"/>
-                </a:solidFill>
-                <a:latin typeface="Calibri" pitchFamily="34" charset="0"/>
-                <a:ea typeface="Calibri" pitchFamily="34" charset="-122"/>
-                <a:cs typeface="Calibri" pitchFamily="34" charset="-120"/>
-              </a:rPr>
-              <a:t>The loss reaches the geometry only through the </a:t>
-            </a:r>
-            <a:r>
-              <a:rPr lang="en-US" sz="1150" b="1" dirty="0">
-                <a:solidFill>
-                  <a:srgbClr val="4493F8"/>
-                </a:solidFill>
-                <a:latin typeface="Calibri" pitchFamily="34" charset="0"/>
-                <a:ea typeface="Calibri" pitchFamily="34" charset="-122"/>
-                <a:cs typeface="Calibri" pitchFamily="34" charset="-120"/>
-              </a:rPr>
-              <a:t>input</a:t>
-            </a:r>
-            <a:r>
-              <a:rPr lang="en-US" sz="1150" dirty="0">
-                <a:solidFill>
-                  <a:srgbClr val="E6EDF3"/>
-                </a:solidFill>
-                <a:latin typeface="Calibri" pitchFamily="34" charset="0"/>
-                <a:ea typeface="Calibri" pitchFamily="34" charset="-122"/>
-                <a:cs typeface="Calibri" pitchFamily="34" charset="-120"/>
-              </a:rPr>
-              <a:t> reads; the positions of targets are treated as constants</a:t>
+              <a:rPr lang="en-US" sz="1050" dirty="0">
+                <a:solidFill>
+                  <a:srgbClr val="E6EDF3"/>
+                </a:solidFill>
+                <a:latin typeface="Calibri" pitchFamily="34" charset="0"/>
+                <a:ea typeface="Calibri" pitchFamily="34" charset="-122"/>
+                <a:cs typeface="Calibri" pitchFamily="34" charset="-120"/>
+              </a:rPr>
+              <a:t>The future cone shares the seven numbers (reflected); an untied arm is the ablation, not the design</a:t>
             </a:r>
             <a:endParaRPr lang="en-US" sz="1250" dirty="0"/>
           </a:p>
@@ -4413,7 +4352,7 @@
         </p:nvSpPr>
         <p:spPr>
           <a:xfrm>
-            <a:off x="4315968" y="3840480"/>
+            <a:off x="548640" y="3840480"/>
             <a:ext cx="3557016" cy="2148840"/>
           </a:xfrm>
           <a:prstGeom prst="roundRect">
@@ -4440,7 +4379,7 @@
         </p:nvSpPr>
         <p:spPr>
           <a:xfrm>
-            <a:off x="4553712" y="3986784"/>
+            <a:off x="786384" y="3986784"/>
             <a:ext cx="3081528" cy="1856232"/>
           </a:xfrm>
           <a:prstGeom prst="rect">
@@ -4468,7 +4407,7 @@
                 <a:ea typeface="Calibri" pitchFamily="34" charset="-122"/>
                 <a:cs typeface="Calibri" pitchFamily="34" charset="-120"/>
               </a:rPr>
-              <a:t>The v2 safety net stays</a:t>
+              <a:t>Stop-gradient on the target side</a:t>
             </a:r>
             <a:endParaRPr lang="en-US" sz="1250" dirty="0"/>
           </a:p>
@@ -4485,7 +4424,29 @@
                 <a:ea typeface="Calibri" pitchFamily="34" charset="-122"/>
                 <a:cs typeface="Calibri" pitchFamily="34" charset="-120"/>
               </a:rPr>
-              <a:t>In addition to the learned ellipse, each lag keeps one fixed log-radial ring of 24 dots to the antipode — the cone can be directed without asserting that a driver could not have come from elsewhere</a:t>
+              <a:t>The loss reaches the geometry only through the </a:t>
+            </a:r>
+            <a:r>
+              <a:rPr lang="en-US" sz="1150" b="1" dirty="0">
+                <a:solidFill>
+                  <a:srgbClr val="4493F8"/>
+                </a:solidFill>
+                <a:latin typeface="Calibri" pitchFamily="34" charset="0"/>
+                <a:ea typeface="Calibri" pitchFamily="34" charset="-122"/>
+                <a:cs typeface="Calibri" pitchFamily="34" charset="-120"/>
+              </a:rPr>
+              <a:t>input</a:t>
+            </a:r>
+            <a:r>
+              <a:rPr lang="en-US" sz="1150" dirty="0">
+                <a:solidFill>
+                  <a:srgbClr val="E6EDF3"/>
+                </a:solidFill>
+                <a:latin typeface="Calibri" pitchFamily="34" charset="0"/>
+                <a:ea typeface="Calibri" pitchFamily="34" charset="-122"/>
+                <a:cs typeface="Calibri" pitchFamily="34" charset="-120"/>
+              </a:rPr>
+              <a:t> reads; the positions of targets are treated as constants</a:t>
             </a:r>
             <a:endParaRPr lang="en-US" sz="1250" dirty="0"/>
           </a:p>
@@ -4499,7 +4460,7 @@
         </p:nvSpPr>
         <p:spPr>
           <a:xfrm>
-            <a:off x="8083296" y="3840480"/>
+            <a:off x="4315968" y="3840480"/>
             <a:ext cx="3557016" cy="2148840"/>
           </a:xfrm>
           <a:prstGeom prst="roundRect">
@@ -4521,6 +4482,92 @@
       <p:sp>
         <p:nvSpPr>
           <p:cNvPr id="18" name="Text 15"/>
+          <p:cNvSpPr txBox="1"/>
+          <p:nvPr/>
+        </p:nvSpPr>
+        <p:spPr>
+          <a:xfrm>
+            <a:off x="4553712" y="3986784"/>
+            <a:ext cx="3081528" cy="1856232"/>
+          </a:xfrm>
+          <a:prstGeom prst="rect">
+            <a:avLst/>
+          </a:prstGeom>
+          <a:noFill/>
+          <a:ln/>
+        </p:spPr>
+        <p:txBody>
+          <a:bodyPr wrap="square" lIns="0" tIns="0" rIns="0" bIns="0" rtlCol="0" anchor="ctr"/>
+          <a:lstStyle/>
+          <a:p>
+            <a:pPr indent="0" marL="0">
+              <a:spcAft>
+                <a:spcPts val="800"/>
+              </a:spcAft>
+              <a:buNone/>
+            </a:pPr>
+            <a:r>
+              <a:rPr lang="en-US" sz="1250" b="1" dirty="0">
+                <a:solidFill>
+                  <a:srgbClr val="4493F8"/>
+                </a:solidFill>
+                <a:latin typeface="Calibri" pitchFamily="34" charset="0"/>
+                <a:ea typeface="Calibri" pitchFamily="34" charset="-122"/>
+                <a:cs typeface="Calibri" pitchFamily="34" charset="-120"/>
+              </a:rPr>
+              <a:t>The v2 safety net stays</a:t>
+            </a:r>
+            <a:endParaRPr lang="en-US" sz="1250" dirty="0"/>
+          </a:p>
+          <a:p>
+            <a:pPr indent="0" marL="0">
+              <a:buNone/>
+            </a:pPr>
+            <a:r>
+              <a:rPr lang="en-US" sz="1150" dirty="0">
+                <a:solidFill>
+                  <a:srgbClr val="E6EDF3"/>
+                </a:solidFill>
+                <a:latin typeface="Calibri" pitchFamily="34" charset="0"/>
+                <a:ea typeface="Calibri" pitchFamily="34" charset="-122"/>
+                <a:cs typeface="Calibri" pitchFamily="34" charset="-120"/>
+              </a:rPr>
+              <a:t>In addition to the learned ellipse, each lag keeps one fixed log-radial ring of 24 dots to the antipode — the cone can be directed without asserting that a driver could not have come from elsewhere</a:t>
+            </a:r>
+            <a:endParaRPr lang="en-US" sz="1250" dirty="0"/>
+          </a:p>
+        </p:txBody>
+      </p:sp>
+      <p:sp>
+        <p:nvSpPr>
+          <p:cNvPr id="19" name="Shape 16"/>
+          <p:cNvSpPr/>
+          <p:nvPr/>
+        </p:nvSpPr>
+        <p:spPr>
+          <a:xfrm>
+            <a:off x="8083296" y="3840480"/>
+            <a:ext cx="3557016" cy="2148840"/>
+          </a:xfrm>
+          <a:prstGeom prst="roundRect">
+            <a:avLst>
+              <a:gd name="adj" fmla="val 2553"/>
+            </a:avLst>
+          </a:prstGeom>
+          <a:solidFill>
+            <a:srgbClr val="161B22"/>
+          </a:solidFill>
+          <a:ln w="12700">
+            <a:solidFill>
+              <a:srgbClr val="30363D"/>
+            </a:solidFill>
+            <a:prstDash val="solid"/>
+          </a:ln>
+        </p:spPr>
+      </p:sp>
+      <p:sp>
+        <p:nvSpPr>
+          <p:cNvPr id="20" name="Text 17"/>
           <p:cNvSpPr txBox="1"/>
           <p:nvPr/>
         </p:nvSpPr>
@@ -4728,7 +4775,7 @@
               <a:buNone/>
             </a:pPr>
             <a:r>
-              <a:rPr lang="en-US" sz="2600" b="1" dirty="0">
+              <a:rPr lang="en-US" sz="2500" b="1" dirty="0">
                 <a:solidFill>
                   <a:srgbClr val="E6EDF3"/>
                 </a:solidFill>
@@ -4736,9 +4783,9 @@
                 <a:ea typeface="Georgia" pitchFamily="34" charset="-122"/>
                 <a:cs typeface="Georgia" pitchFamily="34" charset="-120"/>
               </a:rPr>
-              <a:t>One anchor on the western boundary, two cones pointing opposite ways</a:t>
-            </a:r>
-            <a:endParaRPr lang="en-US" sz="2600" dirty="0"/>
+              <a:t>One anchor on the western boundary: a learned surface cone, and deep profiles read from the other side</a:t>
+            </a:r>
+            <a:endParaRPr lang="en-US" sz="2500" dirty="0"/>
           </a:p>
         </p:txBody>
       </p:sp>
@@ -4900,7 +4947,7 @@
               <a:buChar char="•"/>
             </a:pPr>
             <a:r>
-              <a:rPr lang="en-US" sz="1250" b="1" dirty="0">
+              <a:rPr lang="en-US" sz="1200" b="1" dirty="0">
                 <a:solidFill>
                   <a:srgbClr val="4493F8"/>
                 </a:solidFill>
@@ -4911,17 +4958,17 @@
               <a:t>Surface group:</a:t>
             </a:r>
             <a:r>
-              <a:rPr lang="en-US" sz="1250" dirty="0">
-                <a:solidFill>
-                  <a:srgbClr val="E6EDF3"/>
-                </a:solidFill>
-                <a:latin typeface="Calibri" pitchFamily="34" charset="0"/>
-                <a:ea typeface="Calibri" pitchFamily="34" charset="-122"/>
-                <a:cs typeface="Calibri" pitchFamily="34" charset="-120"/>
-              </a:rPr>
-              <a:t> d points south-west (up the Florida Current, toward the Loop Current); the future cone leans north-east along the Gulf Stream</a:t>
-            </a:r>
-            <a:endParaRPr lang="en-US" sz="1250" dirty="0"/>
+              <a:rPr lang="en-US" sz="1200" dirty="0">
+                <a:solidFill>
+                  <a:srgbClr val="E6EDF3"/>
+                </a:solidFill>
+                <a:latin typeface="Calibri" pitchFamily="34" charset="0"/>
+                <a:ea typeface="Calibri" pitchFamily="34" charset="-122"/>
+                <a:cs typeface="Calibri" pitchFamily="34" charset="-120"/>
+              </a:rPr>
+              <a:t> the learned d should point south-west (up the Florida Current, toward the Loop Current); the future cone leans north-east along the Gulf Stream</a:t>
+            </a:r>
+            <a:endParaRPr lang="en-US" sz="1200" dirty="0"/>
           </a:p>
           <a:p>
             <a:pPr marL="203200" indent="-203200">
@@ -4932,7 +4979,7 @@
               <a:buChar char="•"/>
             </a:pPr>
             <a:r>
-              <a:rPr lang="en-US" sz="1250" b="1" dirty="0">
+              <a:rPr lang="en-US" sz="1200" b="1" dirty="0">
                 <a:solidFill>
                   <a:srgbClr val="4493F8"/>
                 </a:solidFill>
@@ -4940,20 +4987,42 @@
                 <a:ea typeface="Calibri" pitchFamily="34" charset="-122"/>
                 <a:cs typeface="Calibri" pitchFamily="34" charset="-120"/>
               </a:rPr>
-              <a:t>Deep group:</a:t>
-            </a:r>
-            <a:r>
-              <a:rPr lang="en-US" sz="1250" dirty="0">
-                <a:solidFill>
-                  <a:srgbClr val="E6EDF3"/>
-                </a:solidFill>
-                <a:latin typeface="Calibri" pitchFamily="34" charset="0"/>
-                <a:ea typeface="Calibri" pitchFamily="34" charset="-122"/>
-                <a:cs typeface="Calibri" pitchFamily="34" charset="-120"/>
-              </a:rPr>
-              <a:t> d points north along the slope (up the Deep Western Boundary Current); the future cone leans south</a:t>
-            </a:r>
-            <a:endParaRPr lang="en-US" sz="1250" dirty="0"/>
+              <a:t>Deep Argo:</a:t>
+            </a:r>
+            <a:r>
+              <a:rPr lang="en-US" sz="1200" dirty="0">
+                <a:solidFill>
+                  <a:srgbClr val="E6EDF3"/>
+                </a:solidFill>
+                <a:latin typeface="Calibri" pitchFamily="34" charset="0"/>
+                <a:ea typeface="Calibri" pitchFamily="34" charset="-122"/>
+                <a:cs typeface="Calibri" pitchFamily="34" charset="-120"/>
+              </a:rPr>
+              <a:t> no ellipse to learn. The profile tokens within the search radius carry their own offset and depth; the model should put its attention on the deep (&gt; 1000 dbar) profiles </a:t>
+            </a:r>
+            <a:r>
+              <a:rPr lang="en-US" sz="1200" b="1" dirty="0">
+                <a:solidFill>
+                  <a:srgbClr val="4493F8"/>
+                </a:solidFill>
+                <a:latin typeface="Calibri" pitchFamily="34" charset="0"/>
+                <a:ea typeface="Calibri" pitchFamily="34" charset="-122"/>
+                <a:cs typeface="Calibri" pitchFamily="34" charset="-120"/>
+              </a:rPr>
+              <a:t>north</a:t>
+            </a:r>
+            <a:r>
+              <a:rPr lang="en-US" sz="1200" dirty="0">
+                <a:solidFill>
+                  <a:srgbClr val="E6EDF3"/>
+                </a:solidFill>
+                <a:latin typeface="Calibri" pitchFamily="34" charset="0"/>
+                <a:ea typeface="Calibri" pitchFamily="34" charset="-122"/>
+                <a:cs typeface="Calibri" pitchFamily="34" charset="-120"/>
+              </a:rPr>
+              <a:t> of the anchor — up the Deep Western Boundary Current — and on the shallow ones to the south</a:t>
+            </a:r>
+            <a:endParaRPr lang="en-US" sz="1200" dirty="0"/>
           </a:p>
           <a:p>
             <a:pPr marL="203200" indent="-203200">
@@ -4964,7 +5033,7 @@
               <a:buChar char="•"/>
             </a:pPr>
             <a:r>
-              <a:rPr lang="en-US" sz="1250" dirty="0">
+              <a:rPr lang="en-US" sz="1200" dirty="0">
                 <a:solidFill>
                   <a:srgbClr val="E6EDF3"/>
                 </a:solidFill>
@@ -4975,7 +5044,7 @@
               <a:t>Neither is programmed: these are the </a:t>
             </a:r>
             <a:r>
-              <a:rPr lang="en-US" sz="1250" b="1" dirty="0">
+              <a:rPr lang="en-US" sz="1200" b="1" dirty="0">
                 <a:solidFill>
                   <a:srgbClr val="4493F8"/>
                 </a:solidFill>
@@ -4986,17 +5055,17 @@
               <a:t>pre-registered expectations</a:t>
             </a:r>
             <a:r>
-              <a:rPr lang="en-US" sz="1250" dirty="0">
-                <a:solidFill>
-                  <a:srgbClr val="E6EDF3"/>
-                </a:solidFill>
-                <a:latin typeface="Calibri" pitchFamily="34" charset="0"/>
-                <a:ea typeface="Calibri" pitchFamily="34" charset="-122"/>
-                <a:cs typeface="Calibri" pitchFamily="34" charset="-120"/>
-              </a:rPr>
-              <a:t> for the learned maps — the check that the mechanism works</a:t>
-            </a:r>
-            <a:endParaRPr lang="en-US" sz="1250" dirty="0"/>
+              <a:rPr lang="en-US" sz="1200" dirty="0">
+                <a:solidFill>
+                  <a:srgbClr val="E6EDF3"/>
+                </a:solidFill>
+                <a:latin typeface="Calibri" pitchFamily="34" charset="0"/>
+                <a:ea typeface="Calibri" pitchFamily="34" charset="-122"/>
+                <a:cs typeface="Calibri" pitchFamily="34" charset="-120"/>
+              </a:rPr>
+              <a:t> — a geometry check for the surface, an attention check for the deep</a:t>
+            </a:r>
+            <a:endParaRPr lang="en-US" sz="1200" dirty="0"/>
           </a:p>
           <a:p>
             <a:pPr marL="203200" indent="-203200">
@@ -5007,7 +5076,7 @@
               <a:buChar char="•"/>
             </a:pPr>
             <a:r>
-              <a:rPr lang="en-US" sz="1250" dirty="0">
+              <a:rPr lang="en-US" sz="1200" dirty="0">
                 <a:solidFill>
                   <a:srgbClr val="E6EDF3"/>
                 </a:solidFill>
@@ -5017,7 +5086,7 @@
               </a:rPr>
               <a:t>If the learned surface drift correlates with −u_clim (the climatological surface current, reversed) over the world ocean, the cone learned “upstream” from the data alone</a:t>
             </a:r>
-            <a:endParaRPr lang="en-US" sz="1250" dirty="0"/>
+            <a:endParaRPr lang="en-US" sz="1200" dirty="0"/>
           </a:p>
         </p:txBody>
       </p:sp>
@@ -7009,7 +7078,7 @@
                           <a:ea typeface="Calibri" pitchFamily="34" charset="-122"/>
                           <a:cs typeface="Calibri" pitchFamily="34" charset="-120"/>
                         </a:rPr>
-                        <a:t>≈ 0.7 M (slide 10)</a:t>
+                        <a:t>≈ 1.4 M nominal, ~half live (slide 10); no compute</a:t>
                       </a:r>
                       <a:endParaRPr lang="en-US" sz="1100" dirty="0">
                         <a:latin typeface="Calibri" charset="0"/>
@@ -7888,12 +7957,12 @@
         </p:nvSpPr>
         <p:spPr>
           <a:xfrm>
-            <a:off x="548640" y="3694176"/>
-            <a:ext cx="11091672" cy="1115568"/>
+            <a:off x="548640" y="3639312"/>
+            <a:ext cx="11091672" cy="1298448"/>
           </a:xfrm>
           <a:prstGeom prst="roundRect">
             <a:avLst>
-              <a:gd name="adj" fmla="val 4918"/>
+              <a:gd name="adj" fmla="val 4225"/>
             </a:avLst>
           </a:prstGeom>
           <a:solidFill>
@@ -7915,8 +7984,8 @@
         </p:nvSpPr>
         <p:spPr>
           <a:xfrm>
-            <a:off x="822960" y="3858768"/>
-            <a:ext cx="10543032" cy="822960"/>
+            <a:off x="822960" y="3767328"/>
+            <a:ext cx="10543032" cy="1042416"/>
           </a:xfrm>
           <a:prstGeom prst="rect">
             <a:avLst/>
@@ -7930,12 +7999,12 @@
           <a:p>
             <a:pPr indent="0" marL="0">
               <a:spcAft>
-                <a:spcPts val="600"/>
+                <a:spcPts val="500"/>
               </a:spcAft>
               <a:buNone/>
             </a:pPr>
             <a:r>
-              <a:rPr lang="en-US" sz="1150" b="1" dirty="0">
+              <a:rPr lang="en-US" sz="1100" b="1" dirty="0">
                 <a:solidFill>
                   <a:srgbClr val="4493F8"/>
                 </a:solidFill>
@@ -7946,7 +8015,7 @@
               <a:t>R1</a:t>
             </a:r>
             <a:r>
-              <a:rPr lang="en-US" sz="1150" dirty="0">
+              <a:rPr lang="en-US" sz="1100" dirty="0">
                 <a:solidFill>
                   <a:srgbClr val="E6EDF3"/>
                 </a:solidFill>
@@ -7957,7 +8026,7 @@
               <a:t> T1 future-cone loss per lead vs bar  ·  </a:t>
             </a:r>
             <a:r>
-              <a:rPr lang="en-US" sz="1150" b="1" dirty="0">
+              <a:rPr lang="en-US" sz="1100" b="1" dirty="0">
                 <a:solidFill>
                   <a:srgbClr val="4493F8"/>
                 </a:solidFill>
@@ -7968,7 +8037,7 @@
               <a:t>R2</a:t>
             </a:r>
             <a:r>
-              <a:rPr lang="en-US" sz="1150" dirty="0">
+              <a:rPr lang="en-US" sz="1100" dirty="0">
                 <a:solidFill>
                   <a:srgbClr val="E6EDF3"/>
                 </a:solidFill>
@@ -7979,7 +8048,7 @@
               <a:t> the T1 − T2 gap (what history buys)  ·  </a:t>
             </a:r>
             <a:r>
-              <a:rPr lang="en-US" sz="1150" b="1" dirty="0">
+              <a:rPr lang="en-US" sz="1100" b="1" dirty="0">
                 <a:solidFill>
                   <a:srgbClr val="4493F8"/>
                 </a:solidFill>
@@ -7990,7 +8059,7 @@
               <a:t>R3</a:t>
             </a:r>
             <a:r>
-              <a:rPr lang="en-US" sz="1150" dirty="0">
+              <a:rPr lang="en-US" sz="1100" dirty="0">
                 <a:solidFill>
                   <a:srgbClr val="E6EDF3"/>
                 </a:solidFill>
@@ -8000,17 +8069,17 @@
               </a:rPr>
               <a:t> drift-vs-upstream correlation, world ocean, |u_clim| &gt; 0.2 m/s</a:t>
             </a:r>
-            <a:endParaRPr lang="en-US" sz="1150" dirty="0"/>
+            <a:endParaRPr lang="en-US" sz="1100" dirty="0"/>
           </a:p>
           <a:p>
             <a:pPr indent="0" marL="0">
               <a:spcAft>
-                <a:spcPts val="600"/>
+                <a:spcPts val="500"/>
               </a:spcAft>
               <a:buNone/>
             </a:pPr>
             <a:r>
-              <a:rPr lang="en-US" sz="1150" b="1" dirty="0">
+              <a:rPr lang="en-US" sz="1100" b="1" dirty="0">
                 <a:solidFill>
                   <a:srgbClr val="4493F8"/>
                 </a:solidFill>
@@ -8021,18 +8090,27 @@
               <a:t>R4</a:t>
             </a:r>
             <a:r>
-              <a:rPr lang="en-US" sz="1150" dirty="0">
-                <a:solidFill>
-                  <a:srgbClr val="E6EDF3"/>
-                </a:solidFill>
-                <a:latin typeface="Calibri" pitchFamily="34" charset="0"/>
-                <a:ea typeface="Calibri" pitchFamily="34" charset="-122"/>
-                <a:cs typeface="Calibri" pitchFamily="34" charset="-120"/>
-              </a:rPr>
-              <a:t> the western-boundary depth check (surface south-west, deep north)  ·  </a:t>
-            </a:r>
-            <a:r>
-              <a:rPr lang="en-US" sz="1150" b="1" dirty="0">
+              <a:rPr lang="en-US" sz="1100" dirty="0">
+                <a:solidFill>
+                  <a:srgbClr val="E6EDF3"/>
+                </a:solidFill>
+                <a:latin typeface="Calibri" pitchFamily="34" charset="0"/>
+                <a:ea typeface="Calibri" pitchFamily="34" charset="-122"/>
+                <a:cs typeface="Calibri" pitchFamily="34" charset="-120"/>
+              </a:rPr>
+              <a:t> the western-boundary depth check — surface drift south-west (geometry); attention mass on deep (&gt; 1000 dbar) profile tokens north of the anchor, on shallow ones south (attention diagnostic)</a:t>
+            </a:r>
+            <a:endParaRPr lang="en-US" sz="1100" dirty="0"/>
+          </a:p>
+          <a:p>
+            <a:pPr indent="0" marL="0">
+              <a:spcAft>
+                <a:spcPts val="500"/>
+              </a:spcAft>
+              <a:buNone/>
+            </a:pPr>
+            <a:r>
+              <a:rPr lang="en-US" sz="1100" b="1" dirty="0">
                 <a:solidFill>
                   <a:srgbClr val="4493F8"/>
                 </a:solidFill>
@@ -8043,7 +8121,7 @@
               <a:t>R5</a:t>
             </a:r>
             <a:r>
-              <a:rPr lang="en-US" sz="1150" dirty="0">
+              <a:rPr lang="en-US" sz="1100" dirty="0">
                 <a:solidFill>
                   <a:srgbClr val="E6EDF3"/>
                 </a:solidFill>
@@ -8053,7 +8131,7 @@
               </a:rPr>
               <a:t> target-variance flag (slide 13)</a:t>
             </a:r>
-            <a:endParaRPr lang="en-US" sz="1150" dirty="0"/>
+            <a:endParaRPr lang="en-US" sz="1100" dirty="0"/>
           </a:p>
         </p:txBody>
       </p:sp>
@@ -8065,12 +8143,12 @@
         </p:nvSpPr>
         <p:spPr>
           <a:xfrm>
-            <a:off x="548640" y="4919472"/>
-            <a:ext cx="11091672" cy="1234440"/>
+            <a:off x="548640" y="5029200"/>
+            <a:ext cx="11091672" cy="1143000"/>
           </a:xfrm>
           <a:prstGeom prst="roundRect">
             <a:avLst>
-              <a:gd name="adj" fmla="val 4444"/>
+              <a:gd name="adj" fmla="val 4800"/>
             </a:avLst>
           </a:prstGeom>
           <a:solidFill>
@@ -8092,8 +8170,8 @@
         </p:nvSpPr>
         <p:spPr>
           <a:xfrm>
-            <a:off x="822960" y="5065776"/>
-            <a:ext cx="10543032" cy="960120"/>
+            <a:off x="822960" y="5138928"/>
+            <a:ext cx="10543032" cy="923544"/>
           </a:xfrm>
           <a:prstGeom prst="rect">
             <a:avLst/>
@@ -8919,7 +8997,7 @@
                 <a:ea typeface="Calibri" pitchFamily="34" charset="-122"/>
                 <a:cs typeface="Calibri" pitchFamily="34" charset="-120"/>
               </a:rPr>
-              <a:t>2° maps per group, tanh/softplus bounds, mirror, stop-gradient, init = A0; test: at init the dots equal step 1's fixed dots to &lt; 0.1 cell; gradient-check on the seven numbers with finite differences</a:t>
+              <a:t>1° maps per group as coarse 10° + residual, tanh/softplus bounds, the shrinkage/smoothness prior, mirror, stop-gradient, init = A0; test: at init the dots equal step 1's fixed dots to &lt; 0.1 cell; gradient-check on the seven numbers with finite differences</a:t>
             </a:r>
             <a:endParaRPr lang="en-US" sz="1150" dirty="0"/>
           </a:p>
@@ -9060,7 +9138,7 @@
                 <a:ea typeface="Calibri" pitchFamily="34" charset="-122"/>
                 <a:cs typeface="Calibri" pitchFamily="34" charset="-120"/>
               </a:rPr>
-              <a:t>per-task bars, R3/R4 maps exported as data/cone_drift_&lt;group&gt;.json for the app's Cones tab, R5 flag; then the three arms as recipes f7l2-hourglass-{fixed,learned,primed}</a:t>
+              <a:t>per-task bars, R3 drift maps exported as data/cone_drift_&lt;group&gt;.json for the app's Cones tab, R4 attention-by-depth-and-bearing at the western-boundary anchors, R5 flag; then the three arms as recipes f7l2-hourglass-{fixed,learned,primed}</a:t>
             </a:r>
             <a:endParaRPr lang="en-US" sz="1150" dirty="0"/>
           </a:p>
@@ -9201,7 +9279,7 @@
               <a:buNone/>
             </a:pPr>
             <a:r>
-              <a:rPr lang="en-US" sz="2300" b="1" dirty="0">
+              <a:rPr lang="en-US" sz="2800" b="1" dirty="0">
                 <a:solidFill>
                   <a:srgbClr val="E6EDF3"/>
                 </a:solidFill>
@@ -9209,9 +9287,9 @@
                 <a:ea typeface="Georgia" pitchFamily="34" charset="-122"/>
                 <a:cs typeface="Georgia" pitchFamily="34" charset="-120"/>
               </a:rPr>
-              <a:t>Six choices the deck took a position on — all reversible</a:t>
-            </a:r>
-            <a:endParaRPr lang="en-US" sz="2300" dirty="0"/>
+              <a:t>Two settled, five still open — all reversible</a:t>
+            </a:r>
+            <a:endParaRPr lang="en-US" sz="2800" dirty="0"/>
           </a:p>
         </p:txBody>
       </p:sp>
@@ -9301,12 +9379,122 @@
         </p:nvSpPr>
         <p:spPr>
           <a:xfrm>
-            <a:off x="548640" y="1554480"/>
-            <a:ext cx="3557016" cy="1828800"/>
+            <a:off x="548640" y="1444752"/>
+            <a:ext cx="11091672" cy="841248"/>
           </a:xfrm>
           <a:prstGeom prst="roundRect">
             <a:avLst>
-              <a:gd name="adj" fmla="val 3000"/>
+              <a:gd name="adj" fmla="val 6522"/>
+            </a:avLst>
+          </a:prstGeom>
+          <a:solidFill>
+            <a:srgbClr val="11202F"/>
+          </a:solidFill>
+          <a:ln w="12700">
+            <a:solidFill>
+              <a:srgbClr val="E3B341"/>
+            </a:solidFill>
+            <a:prstDash val="solid"/>
+          </a:ln>
+        </p:spPr>
+      </p:sp>
+      <p:sp>
+        <p:nvSpPr>
+          <p:cNvPr id="8" name="Text 5"/>
+          <p:cNvSpPr txBox="1"/>
+          <p:nvPr/>
+        </p:nvSpPr>
+        <p:spPr>
+          <a:xfrm>
+            <a:off x="822960" y="1591056"/>
+            <a:ext cx="10543032" cy="566928"/>
+          </a:xfrm>
+          <a:prstGeom prst="rect">
+            <a:avLst/>
+          </a:prstGeom>
+          <a:noFill/>
+          <a:ln/>
+        </p:spPr>
+        <p:txBody>
+          <a:bodyPr wrap="square" lIns="0" tIns="0" rIns="0" bIns="0" rtlCol="0" anchor="ctr"/>
+          <a:lstStyle/>
+          <a:p>
+            <a:pPr indent="0" marL="0">
+              <a:buNone/>
+            </a:pPr>
+            <a:r>
+              <a:rPr lang="en-US" sz="1250" b="1" dirty="0">
+                <a:solidFill>
+                  <a:srgbClr val="E3B341"/>
+                </a:solidFill>
+                <a:latin typeface="Calibri" pitchFamily="34" charset="0"/>
+                <a:ea typeface="Calibri" pitchFamily="34" charset="-122"/>
+                <a:cs typeface="Calibri" pitchFamily="34" charset="-120"/>
+              </a:rPr>
+              <a:t>Settled 15 Sep (Chris):  </a:t>
+            </a:r>
+            <a:r>
+              <a:rPr lang="en-US" sz="1250" b="1" dirty="0">
+                <a:solidFill>
+                  <a:srgbClr val="4493F8"/>
+                </a:solidFill>
+                <a:latin typeface="Calibri" pitchFamily="34" charset="0"/>
+                <a:ea typeface="Calibri" pitchFamily="34" charset="-122"/>
+                <a:cs typeface="Calibri" pitchFamily="34" charset="-120"/>
+              </a:rPr>
+              <a:t>1°</a:t>
+            </a:r>
+            <a:r>
+              <a:rPr lang="en-US" sz="1250" dirty="0">
+                <a:solidFill>
+                  <a:srgbClr val="E6EDF3"/>
+                </a:solidFill>
+                <a:latin typeface="Calibri" pitchFamily="34" charset="0"/>
+                <a:ea typeface="Calibri" pitchFamily="34" charset="-122"/>
+                <a:cs typeface="Calibri" pitchFamily="34" charset="-120"/>
+              </a:rPr>
+              <a:t> parameter maps with the coarse-plus-residual prior; </a:t>
+            </a:r>
+            <a:r>
+              <a:rPr lang="en-US" sz="1250" b="1" dirty="0">
+                <a:solidFill>
+                  <a:srgbClr val="4493F8"/>
+                </a:solidFill>
+                <a:latin typeface="Calibri" pitchFamily="34" charset="0"/>
+                <a:ea typeface="Calibri" pitchFamily="34" charset="-122"/>
+                <a:cs typeface="Calibri" pitchFamily="34" charset="-120"/>
+              </a:rPr>
+              <a:t>no Argo ellipses</a:t>
+            </a:r>
+            <a:r>
+              <a:rPr lang="en-US" sz="1250" dirty="0">
+                <a:solidFill>
+                  <a:srgbClr val="E6EDF3"/>
+                </a:solidFill>
+                <a:latin typeface="Calibri" pitchFamily="34" charset="0"/>
+                <a:ea typeface="Calibri" pitchFamily="34" charset="-122"/>
+                <a:cs typeface="Calibri" pitchFamily="34" charset="-120"/>
+              </a:rPr>
+              <a:t> — the nearest-profile tokens stay as E-071 §3 specifies them.</a:t>
+            </a:r>
+            <a:endParaRPr lang="en-US" sz="1250" dirty="0"/>
+          </a:p>
+        </p:txBody>
+      </p:sp>
+      <p:sp>
+        <p:nvSpPr>
+          <p:cNvPr id="9" name="Shape 6"/>
+          <p:cNvSpPr/>
+          <p:nvPr/>
+        </p:nvSpPr>
+        <p:spPr>
+          <a:xfrm>
+            <a:off x="548640" y="2468880"/>
+            <a:ext cx="3557016" cy="1691640"/>
+          </a:xfrm>
+          <a:prstGeom prst="roundRect">
+            <a:avLst>
+              <a:gd name="adj" fmla="val 3243"/>
             </a:avLst>
           </a:prstGeom>
           <a:solidFill>
@@ -9322,14 +9510,14 @@
       </p:sp>
       <p:sp>
         <p:nvSpPr>
-          <p:cNvPr id="8" name="Text 5"/>
+          <p:cNvPr id="10" name="Text 7"/>
           <p:cNvSpPr txBox="1"/>
           <p:nvPr/>
         </p:nvSpPr>
         <p:spPr>
           <a:xfrm>
-            <a:off x="786384" y="1700784"/>
-            <a:ext cx="3081528" cy="1536192"/>
+            <a:off x="786384" y="2615184"/>
+            <a:ext cx="3081528" cy="1399032"/>
           </a:xfrm>
           <a:prstGeom prst="rect">
             <a:avLst/>
@@ -9365,7 +9553,7 @@
               <a:buNone/>
             </a:pPr>
             <a:r>
-              <a:rPr lang="en-US" sz="1200" b="1" dirty="0">
+              <a:rPr lang="en-US" sz="1150" b="1" dirty="0">
                 <a:solidFill>
                   <a:srgbClr val="4493F8"/>
                 </a:solidFill>
@@ -9376,7 +9564,7 @@
               <a:t>+6 pentads</a:t>
             </a:r>
             <a:r>
-              <a:rPr lang="en-US" sz="1200" dirty="0">
+              <a:rPr lang="en-US" sz="1150" dirty="0">
                 <a:solidFill>
                   <a:srgbClr val="E6EDF3"/>
                 </a:solidFill>
@@ -9392,18 +9580,18 @@
       </p:sp>
       <p:sp>
         <p:nvSpPr>
-          <p:cNvPr id="9" name="Shape 6"/>
+          <p:cNvPr id="11" name="Shape 8"/>
           <p:cNvSpPr/>
           <p:nvPr/>
         </p:nvSpPr>
         <p:spPr>
           <a:xfrm>
-            <a:off x="4315968" y="1554480"/>
-            <a:ext cx="3557016" cy="1828800"/>
+            <a:off x="4315968" y="2468880"/>
+            <a:ext cx="3557016" cy="1691640"/>
           </a:xfrm>
           <a:prstGeom prst="roundRect">
             <a:avLst>
-              <a:gd name="adj" fmla="val 3000"/>
+              <a:gd name="adj" fmla="val 3243"/>
             </a:avLst>
           </a:prstGeom>
           <a:solidFill>
@@ -9419,14 +9607,14 @@
       </p:sp>
       <p:sp>
         <p:nvSpPr>
-          <p:cNvPr id="10" name="Text 7"/>
+          <p:cNvPr id="12" name="Text 9"/>
           <p:cNvSpPr txBox="1"/>
           <p:nvPr/>
         </p:nvSpPr>
         <p:spPr>
           <a:xfrm>
-            <a:off x="4553712" y="1700784"/>
-            <a:ext cx="3081528" cy="1536192"/>
+            <a:off x="4553712" y="2615184"/>
+            <a:ext cx="3081528" cy="1399032"/>
           </a:xfrm>
           <a:prstGeom prst="rect">
             <a:avLst/>
@@ -9462,7 +9650,7 @@
               <a:buNone/>
             </a:pPr>
             <a:r>
-              <a:rPr lang="en-US" sz="1200" b="1" dirty="0">
+              <a:rPr lang="en-US" sz="1150" b="1" dirty="0">
                 <a:solidFill>
                   <a:srgbClr val="4493F8"/>
                 </a:solidFill>
@@ -9473,7 +9661,7 @@
               <a:t>0.35 / 0.15 / 0.25 / 0.25</a:t>
             </a:r>
             <a:r>
-              <a:rPr lang="en-US" sz="1200" dirty="0">
+              <a:rPr lang="en-US" sz="1150" dirty="0">
                 <a:solidFill>
                   <a:srgbClr val="E6EDF3"/>
                 </a:solidFill>
@@ -9489,18 +9677,18 @@
       </p:sp>
       <p:sp>
         <p:nvSpPr>
-          <p:cNvPr id="11" name="Shape 8"/>
+          <p:cNvPr id="13" name="Shape 10"/>
           <p:cNvSpPr/>
           <p:nvPr/>
         </p:nvSpPr>
         <p:spPr>
           <a:xfrm>
-            <a:off x="8083296" y="1554480"/>
-            <a:ext cx="3557016" cy="1828800"/>
+            <a:off x="8083296" y="2468880"/>
+            <a:ext cx="3557016" cy="1691640"/>
           </a:xfrm>
           <a:prstGeom prst="roundRect">
             <a:avLst>
-              <a:gd name="adj" fmla="val 3000"/>
+              <a:gd name="adj" fmla="val 3243"/>
             </a:avLst>
           </a:prstGeom>
           <a:solidFill>
@@ -9516,14 +9704,14 @@
       </p:sp>
       <p:sp>
         <p:nvSpPr>
-          <p:cNvPr id="12" name="Text 9"/>
+          <p:cNvPr id="14" name="Text 11"/>
           <p:cNvSpPr txBox="1"/>
           <p:nvPr/>
         </p:nvSpPr>
         <p:spPr>
           <a:xfrm>
-            <a:off x="8321040" y="1700784"/>
-            <a:ext cx="3081528" cy="1536192"/>
+            <a:off x="8321040" y="2615184"/>
+            <a:ext cx="3081528" cy="1399032"/>
           </a:xfrm>
           <a:prstGeom prst="rect">
             <a:avLst/>
@@ -9550,7 +9738,7 @@
                 <a:ea typeface="Calibri" pitchFamily="34" charset="-122"/>
                 <a:cs typeface="Calibri" pitchFamily="34" charset="-120"/>
               </a:rPr>
-              <a:t>Parameter maps</a:t>
+              <a:t>Prior strength on the 1° residual</a:t>
             </a:r>
             <a:endParaRPr lang="en-US" sz="1250" dirty="0"/>
           </a:p>
@@ -9559,26 +9747,15 @@
               <a:buNone/>
             </a:pPr>
             <a:r>
-              <a:rPr lang="en-US" sz="1200" b="1" dirty="0">
-                <a:solidFill>
-                  <a:srgbClr val="4493F8"/>
-                </a:solidFill>
-                <a:latin typeface="Calibri" pitchFamily="34" charset="0"/>
-                <a:ea typeface="Calibri" pitchFamily="34" charset="-122"/>
-                <a:cs typeface="Calibri" pitchFamily="34" charset="-120"/>
-              </a:rPr>
-              <a:t>2°</a:t>
-            </a:r>
-            <a:r>
-              <a:rPr lang="en-US" sz="1200" dirty="0">
-                <a:solidFill>
-                  <a:srgbClr val="E6EDF3"/>
-                </a:solidFill>
-                <a:latin typeface="Calibri" pitchFamily="34" charset="0"/>
-                <a:ea typeface="Calibri" pitchFamily="34" charset="-122"/>
-                <a:cs typeface="Calibri" pitchFamily="34" charset="-120"/>
-              </a:rPr>
-              <a:t> grids; 1° doubles resolution at 4× the (small) parameter cost</a:t>
+              <a:rPr lang="en-US" sz="1150" dirty="0">
+                <a:solidFill>
+                  <a:srgbClr val="E6EDF3"/>
+                </a:solidFill>
+                <a:latin typeface="Calibri" pitchFamily="34" charset="0"/>
+                <a:ea typeface="Calibri" pitchFamily="34" charset="-122"/>
+                <a:cs typeface="Calibri" pitchFamily="34" charset="-120"/>
+              </a:rPr>
+              <a:t>One weight, to be set by held-out loss on the training years — or fixed by hand for the first arm?</a:t>
             </a:r>
             <a:endParaRPr lang="en-US" sz="1250" dirty="0"/>
           </a:p>
@@ -9586,18 +9763,18 @@
       </p:sp>
       <p:sp>
         <p:nvSpPr>
-          <p:cNvPr id="13" name="Shape 10"/>
+          <p:cNvPr id="15" name="Shape 12"/>
           <p:cNvSpPr/>
           <p:nvPr/>
         </p:nvSpPr>
         <p:spPr>
           <a:xfrm>
-            <a:off x="548640" y="3703320"/>
-            <a:ext cx="3557016" cy="1828800"/>
+            <a:off x="548640" y="4343400"/>
+            <a:ext cx="5440680" cy="1691640"/>
           </a:xfrm>
           <a:prstGeom prst="roundRect">
             <a:avLst>
-              <a:gd name="adj" fmla="val 3000"/>
+              <a:gd name="adj" fmla="val 3243"/>
             </a:avLst>
           </a:prstGeom>
           <a:solidFill>
@@ -9613,14 +9790,14 @@
       </p:sp>
       <p:sp>
         <p:nvSpPr>
-          <p:cNvPr id="14" name="Text 11"/>
+          <p:cNvPr id="16" name="Text 13"/>
           <p:cNvSpPr txBox="1"/>
           <p:nvPr/>
         </p:nvSpPr>
         <p:spPr>
           <a:xfrm>
-            <a:off x="786384" y="3849624"/>
-            <a:ext cx="3081528" cy="1536192"/>
+            <a:off x="786384" y="4489704"/>
+            <a:ext cx="4965192" cy="1399032"/>
           </a:xfrm>
           <a:prstGeom prst="rect">
             <a:avLst/>
@@ -9647,7 +9824,7 @@
                 <a:ea typeface="Calibri" pitchFamily="34" charset="-122"/>
                 <a:cs typeface="Calibri" pitchFamily="34" charset="-120"/>
               </a:rPr>
-              <a:t>Argo depth groups</a:t>
+              <a:t>The v2 safety ring</a:t>
             </a:r>
             <a:endParaRPr lang="en-US" sz="1250" dirty="0"/>
           </a:p>
@@ -9656,18 +9833,7 @@
               <a:buNone/>
             </a:pPr>
             <a:r>
-              <a:rPr lang="en-US" sz="1200" dirty="0">
-                <a:solidFill>
-                  <a:srgbClr val="E6EDF3"/>
-                </a:solidFill>
-                <a:latin typeface="Calibri" pitchFamily="34" charset="0"/>
-                <a:ea typeface="Calibri" pitchFamily="34" charset="-122"/>
-                <a:cs typeface="Calibri" pitchFamily="34" charset="-120"/>
-              </a:rPr>
-              <a:t>Split at </a:t>
-            </a:r>
-            <a:r>
-              <a:rPr lang="en-US" sz="1200" b="1" dirty="0">
+              <a:rPr lang="en-US" sz="1150" b="1" dirty="0">
                 <a:solidFill>
                   <a:srgbClr val="4493F8"/>
                 </a:solidFill>
@@ -9675,18 +9841,18 @@
                 <a:ea typeface="Calibri" pitchFamily="34" charset="-122"/>
                 <a:cs typeface="Calibri" pitchFamily="34" charset="-120"/>
               </a:rPr>
-              <a:t>300 and 1000 dbar</a:t>
-            </a:r>
-            <a:r>
-              <a:rPr lang="en-US" sz="1200" dirty="0">
-                <a:solidFill>
-                  <a:srgbClr val="E6EDF3"/>
-                </a:solidFill>
-                <a:latin typeface="Calibri" pitchFamily="34" charset="0"/>
-                <a:ea typeface="Calibri" pitchFamily="34" charset="-122"/>
-                <a:cs typeface="Calibri" pitchFamily="34" charset="-120"/>
-              </a:rPr>
-              <a:t> for the Argo cones</a:t>
+              <a:t>Kept</a:t>
+            </a:r>
+            <a:r>
+              <a:rPr lang="en-US" sz="1150" dirty="0">
+                <a:solidFill>
+                  <a:srgbClr val="E6EDF3"/>
+                </a:solidFill>
+                <a:latin typeface="Calibri" pitchFamily="34" charset="0"/>
+                <a:ea typeface="Calibri" pitchFamily="34" charset="-122"/>
+                <a:cs typeface="Calibri" pitchFamily="34" charset="-120"/>
+              </a:rPr>
+              <a:t> at every lag (24 tokens per lag per group); dropping it halves the past-cone tokens but restores v2's “too narrow” risk</a:t>
             </a:r>
             <a:endParaRPr lang="en-US" sz="1250" dirty="0"/>
           </a:p>
@@ -9694,18 +9860,18 @@
       </p:sp>
       <p:sp>
         <p:nvSpPr>
-          <p:cNvPr id="15" name="Shape 12"/>
+          <p:cNvPr id="17" name="Shape 14"/>
           <p:cNvSpPr/>
           <p:nvPr/>
         </p:nvSpPr>
         <p:spPr>
           <a:xfrm>
-            <a:off x="4315968" y="3703320"/>
-            <a:ext cx="3557016" cy="1828800"/>
+            <a:off x="6199632" y="4343400"/>
+            <a:ext cx="5440680" cy="1691640"/>
           </a:xfrm>
           <a:prstGeom prst="roundRect">
             <a:avLst>
-              <a:gd name="adj" fmla="val 3000"/>
+              <a:gd name="adj" fmla="val 3243"/>
             </a:avLst>
           </a:prstGeom>
           <a:solidFill>
@@ -9721,14 +9887,14 @@
       </p:sp>
       <p:sp>
         <p:nvSpPr>
-          <p:cNvPr id="16" name="Text 13"/>
+          <p:cNvPr id="18" name="Text 15"/>
           <p:cNvSpPr txBox="1"/>
           <p:nvPr/>
         </p:nvSpPr>
         <p:spPr>
           <a:xfrm>
-            <a:off x="4553712" y="3849624"/>
-            <a:ext cx="3081528" cy="1536192"/>
+            <a:off x="6437376" y="4489704"/>
+            <a:ext cx="4965192" cy="1399032"/>
           </a:xfrm>
           <a:prstGeom prst="rect">
             <a:avLst/>
@@ -9755,7 +9921,7 @@
                 <a:ea typeface="Calibri" pitchFamily="34" charset="-122"/>
                 <a:cs typeface="Calibri" pitchFamily="34" charset="-120"/>
               </a:rPr>
-              <a:t>The v2 safety ring</a:t>
+              <a:t>Seasonal drift term</a:t>
             </a:r>
             <a:endParaRPr lang="en-US" sz="1250" dirty="0"/>
           </a:p>
@@ -9764,7 +9930,7 @@
               <a:buNone/>
             </a:pPr>
             <a:r>
-              <a:rPr lang="en-US" sz="1200" b="1" dirty="0">
+              <a:rPr lang="en-US" sz="1150" b="1" dirty="0">
                 <a:solidFill>
                   <a:srgbClr val="4493F8"/>
                 </a:solidFill>
@@ -9772,107 +9938,10 @@
                 <a:ea typeface="Calibri" pitchFamily="34" charset="-122"/>
                 <a:cs typeface="Calibri" pitchFamily="34" charset="-120"/>
               </a:rPr>
-              <a:t>Kept</a:t>
-            </a:r>
-            <a:r>
-              <a:rPr lang="en-US" sz="1200" dirty="0">
-                <a:solidFill>
-                  <a:srgbClr val="E6EDF3"/>
-                </a:solidFill>
-                <a:latin typeface="Calibri" pitchFamily="34" charset="0"/>
-                <a:ea typeface="Calibri" pitchFamily="34" charset="-122"/>
-                <a:cs typeface="Calibri" pitchFamily="34" charset="-120"/>
-              </a:rPr>
-              <a:t> at every lag (24 tokens per lag per group); dropping it halves the past-cone tokens but restores v2's “too narrow” risk</a:t>
-            </a:r>
-            <a:endParaRPr lang="en-US" sz="1250" dirty="0"/>
-          </a:p>
-        </p:txBody>
-      </p:sp>
-      <p:sp>
-        <p:nvSpPr>
-          <p:cNvPr id="17" name="Shape 14"/>
-          <p:cNvSpPr/>
-          <p:nvPr/>
-        </p:nvSpPr>
-        <p:spPr>
-          <a:xfrm>
-            <a:off x="8083296" y="3703320"/>
-            <a:ext cx="3557016" cy="1828800"/>
-          </a:xfrm>
-          <a:prstGeom prst="roundRect">
-            <a:avLst>
-              <a:gd name="adj" fmla="val 3000"/>
-            </a:avLst>
-          </a:prstGeom>
-          <a:solidFill>
-            <a:srgbClr val="161B22"/>
-          </a:solidFill>
-          <a:ln w="12700">
-            <a:solidFill>
-              <a:srgbClr val="30363D"/>
-            </a:solidFill>
-            <a:prstDash val="solid"/>
-          </a:ln>
-        </p:spPr>
-      </p:sp>
-      <p:sp>
-        <p:nvSpPr>
-          <p:cNvPr id="18" name="Text 15"/>
-          <p:cNvSpPr txBox="1"/>
-          <p:nvPr/>
-        </p:nvSpPr>
-        <p:spPr>
-          <a:xfrm>
-            <a:off x="8321040" y="3849624"/>
-            <a:ext cx="3081528" cy="1536192"/>
-          </a:xfrm>
-          <a:prstGeom prst="rect">
-            <a:avLst/>
-          </a:prstGeom>
-          <a:noFill/>
-          <a:ln/>
-        </p:spPr>
-        <p:txBody>
-          <a:bodyPr wrap="square" lIns="0" tIns="0" rIns="0" bIns="0" rtlCol="0" anchor="ctr"/>
-          <a:lstStyle/>
-          <a:p>
-            <a:pPr indent="0" marL="0">
-              <a:spcAft>
-                <a:spcPts val="800"/>
-              </a:spcAft>
-              <a:buNone/>
-            </a:pPr>
-            <a:r>
-              <a:rPr lang="en-US" sz="1250" b="1" dirty="0">
-                <a:solidFill>
-                  <a:srgbClr val="4493F8"/>
-                </a:solidFill>
-                <a:latin typeface="Calibri" pitchFamily="34" charset="0"/>
-                <a:ea typeface="Calibri" pitchFamily="34" charset="-122"/>
-                <a:cs typeface="Calibri" pitchFamily="34" charset="-120"/>
-              </a:rPr>
-              <a:t>Seasonal drift term</a:t>
-            </a:r>
-            <a:endParaRPr lang="en-US" sz="1250" dirty="0"/>
-          </a:p>
-          <a:p>
-            <a:pPr indent="0" marL="0">
-              <a:buNone/>
-            </a:pPr>
-            <a:r>
-              <a:rPr lang="en-US" sz="1200" b="1" dirty="0">
-                <a:solidFill>
-                  <a:srgbClr val="4493F8"/>
-                </a:solidFill>
-                <a:latin typeface="Calibri" pitchFamily="34" charset="0"/>
-                <a:ea typeface="Calibri" pitchFamily="34" charset="-122"/>
-                <a:cs typeface="Calibri" pitchFamily="34" charset="-120"/>
-              </a:rPr>
               <a:t>Deferred</a:t>
             </a:r>
             <a:r>
-              <a:rPr lang="en-US" sz="1200" dirty="0">
+              <a:rPr lang="en-US" sz="1150" dirty="0">
                 <a:solidFill>
                   <a:srgbClr val="E6EDF3"/>
                 </a:solidFill>

</xml_diff>

<commit_message>
E-080 revision 3.1: golden-angle phase per lag, a learned memory per channel; handover note and deck build scripts
Chris asked whether time is sunflower-sampled. It is not, by design (dense
pentads inside the 30-day window; stage 2 owns the long window), but a stack
of identical slices repeats the same bearings at every lag, so the sunflower's
phase now advances by the golden angle per lag and the slices interleave in
space-time. The per-channel aperture gains a time factor exp(−ℓΔt/τ_c) with a
learned memory τ_c per channel, initialised from FAMILIES.tau_days, so the
hard "wind stress reads lags 0–1 only" rule becomes a soft, learnable weight.
Adds ml/plans/E080_HANDOVER.md for the next agent and ml/plans/E080_build/
so the deck can be rebuilt from the plan. Still design only.

Co-Authored-By: Claude Fable 5.1 <noreply@anthropic.com>
Claude-Session: https://claude.ai/code/session_01D2J1M6bHDVYWvgiF1PyUvg
</commit_message>
<xml_diff>
--- a/ml/plans/E080_hourglass_cone_deck.pptx
+++ b/ml/plans/E080_hourglass_cone_deck.pptx
@@ -609,7 +609,7 @@
           <a:p>
             <a:r>
               <a:rPr lang="en-US" dirty="0"/>
-              <a:t>The mechanism that makes a per-channel scale free is the per-location token, which cone v2 introduced in its section 6.4: instead of one token per channel per dot — the E-069 layout, seven hundred and six dot tokens for a handful of channels — one token per dot that carries every channel of the group as a vector of values and a vector of observed flags. Each channel's entries in that vector are multiplied by that channel's own aperture weight at that dot before the token is projected into the model. The weight is a Gaussian of the dot's offset under the channel's covariance: near the centre it is one, far outside the channel's aperture it is essentially zero. So a dot four hundred kilometres from the anchor at lag one is read by the currents at about thirty percent — their initial aperture is two hundred and sixty kilometres — and by sea-surface temperature at about seventy percent, because its initial aperture at that lag is five hundred. Same token, same read, two different weights. No new tokens, no new reads, one elementwise multiply per token. And because the weight is a smooth function of the shared shape, the shared drift and the channel's own offset, the loss reaches all three through every dot at once — a far better gradient than the four-neighbouring-cells one that reading at interpolated positions would give, and the reason the next slide can let the geometry learn without the data loader knowing where it currently is. One exception, stated once: the fixed far ring of cone v2 is never gated. It is the safety net, and a safety net the model can switch off is not one.</a:t>
+              <a:t>The mechanism that makes a per-channel scale free is the per-location token, which cone v2 introduced in its section 6.4: instead of one token per channel per dot — the E-069 layout, seven hundred and six dot tokens for a handful of channels — one token per dot that carries every channel of the group as a vector of values and a vector of observed flags. Each channel's entries in that vector are multiplied by that channel's own aperture weight at that dot before the token is projected into the model. The weight has two factors. In space it is a Gaussian of the dot's offset under the channel's covariance: near the centre it is one, far outside the channel's aperture it is essentially zero. In time it is an exponential decay over lag with the channel's own memory, so a channel with a ten-day memory reads lag four at about fourteen percent — the hard "lags zero and one only" rule for wind stress, turned into a soft weight the model can move. So a dot four hundred kilometres from the anchor at lag one is read by the currents at about thirty percent — their initial aperture is two hundred and sixty kilometres — and by sea-surface temperature at about seventy percent, because its initial aperture at that lag is five hundred. Same token, same read, two different weights. No new tokens, no new reads, one elementwise multiply per token. And because the weight is a smooth function of the shared shape, the shared drift and the channel's own scale and memory, the loss reaches all four through every dot at once — a far better gradient than the four-neighbouring-cells one that reading at interpolated positions would give, and the reason the next slide can let the geometry learn without the data loader knowing where it currently is. One exception, stated once: the fixed far ring of cone v2 is never gated. It is the safety net, and a safety net the model can switch off is not one.</a:t>
             </a:r>
             <a:endParaRPr lang="en-US" dirty="0"/>
           </a:p>
@@ -785,7 +785,7 @@
           <a:p>
             <a:r>
               <a:rPr lang="en-US" dirty="0"/>
-              <a:t>Where do the eight numbers live? On a one-degree map. A one-degree grid over the globe has about sixty-five thousand cells; an anchor takes the blend of the four cells around it, so the geometry varies smoothly and never jumps at a cell edge. One degree is not a round number picked for comfort: the currents that carry the overturning are about a hundred kilometres wide — the Florida Current runs through an eighty-kilometre strait — and a ten-degree cell would average the Gulf Stream with the water flowing back the other way beside it and learn an arrow of nearly zero. The concern with a fine map is noise in cells that see little data, at the ice edge or along coasts. The answer is a hierarchical prior rather than a coarser map: every map is a coarse ten-degree map plus a one-degree residual, and the residual is shrunk toward zero and smoothed toward its neighbours, so a cell with little evidence inherits the arrow of its region. Even so, each one-degree cell sees about fifty thousand anchor-pentads for its eight numbers. There is one map per channel group, because what moves a signal decides where its source is: the ocean surface group, the atmosphere group with drift only inside its ten-day memory, and the land group, which does not advect and learns only axes and angle. Argo gets no map at all. Its channels arrive as the nearest profile tokens, placed where the floats actually were, each carrying its own offset, age and depth — there is no ellipse there to learn, and the earlier draft's three depth maps were a leftover from the column-only Argo of E-069. The physics that motivated them still matters — at the RAPID line the upper limb flows north and the deep boundary current south — but a token that carries its own depth and offset lets attention weight deep tokens from the north and surface tokens from the south by itself. That becomes a diagnostic rather than a geometry. All told the maps hold about one and a half million numbers, half of them live, plus a few dozen per-channel scale offsets that are global rather than per region, and none of it costs compute.</a:t>
+              <a:t>Where do the eight numbers live? On a one-degree map. A one-degree grid over the globe has about sixty-five thousand cells; an anchor takes the blend of the four cells around it, so the geometry varies smoothly and never jumps at a cell edge. One degree is not a round number picked for comfort: the currents that carry the overturning are about a hundred kilometres wide — the Florida Current runs through an eighty-kilometre strait — and a ten-degree cell would average the Gulf Stream with the water flowing back the other way beside it and learn an arrow of nearly zero. The concern with a fine map is noise in cells that see little data, at the ice edge or along coasts. The answer is a hierarchical prior rather than a coarser map: every map is a coarse ten-degree map plus a one-degree residual, and the residual is shrunk toward zero and smoothed toward its neighbours, so a cell with little evidence inherits the arrow of its region. Even so, each one-degree cell sees about fifty thousand anchor-pentads for its eight numbers. There is one map per channel group, because what moves a signal decides where its source is: the ocean surface group, the atmosphere group with drift only inside its ten-day memory, and the land group, which does not advect and learns only axes and angle. Argo gets no map at all. Its channels arrive as the nearest profile tokens, placed where the floats actually were, each carrying its own offset, age and depth — there is no ellipse there to learn, and the earlier draft's three depth maps were a leftover from the column-only Argo of E-069. The physics that motivated them still matters — at the RAPID line the upper limb flows north and the deep boundary current south — but a token that carries its own depth and offset lets attention weight deep tokens from the north and surface tokens from the south by itself. That becomes a diagnostic rather than a geometry. All told the maps hold about one and a half million numbers, half of them live, plus a hundred or so per-channel scales and memories that are global rather than per region, and none of it costs compute.</a:t>
             </a:r>
             <a:endParaRPr lang="en-US" dirty="0"/>
           </a:p>
@@ -1401,7 +1401,7 @@
           <a:p>
             <a:r>
               <a:rPr lang="en-US" dirty="0"/>
-              <a:t>Two choices are settled: the maps are at one degree with the coarse-plus-residual prior, and Argo keeps its nearest-profile tokens with no ellipse. Six remain, each one line to change. The future cone goes to six pentads to mirror the past, where E-069 only asked for one and two. The task shares are a first guess. The strength of the prior on the fine map is one number, and the honest way to set it is by held-out loss on the training years rather than by hand — but the first arm may simply fix it. The v2 safety ring is kept at every lag, which is the safe and more expensive choice. The seasonal term on the drift waits for phase two. And the harden interval and the geometry learning-rate multiplier are first guesses that every run records. Say the word on any of these and the spec changes; none of them affects the build order.</a:t>
+              <a:t>Two choices are settled: the maps are at one degree with the coarse-plus-residual prior, and Argo keeps its nearest-profile tokens with no ellipse. Seven remain, each one line to change. The future cone goes to six pentads to mirror the past, where E-069 only asked for one and two. The task shares are a first guess. The strength of the prior on the fine map is one number, and the honest way to set it is by held-out loss on the training years rather than by hand — but the first arm may simply fix it. The v2 safety ring is kept at every lag, which is the safe and more expensive choice. The seasonal term on the drift waits for phase two. The harden interval and the geometry learning-rate multiplier are first guesses that every run records. And time stays dense inside the thirty-day window, one slice per pentad; a log-spaced time ramp that would stretch six slices over sixty-five days is listed as an ablation because it would move the codec's window into stage two's territory, which cone v2 deliberately separated in time. Say the word on any of these and the spec changes; none of them affects the build order.</a:t>
             </a:r>
             <a:endParaRPr lang="en-US" dirty="0"/>
           </a:p>
@@ -2105,7 +2105,7 @@
           <a:p>
             <a:r>
               <a:rPr lang="en-US" dirty="0"/>
-              <a:t>Point four, the proposal, in its revision-3 form. The cone at a given lag is a Gaussian footprint: a centre, and a covariance that says how wide it is and in which direction it is stretched. The dots are the fixed sunflower — the same twenty-four-point pattern the project has used since E-026, the experiment that introduced the sunflower stencil for stage two — pushed through that covariance, so the pattern is squashed, stretched and shifted but never re-invented. Eight numbers per region and channel group define it. Two are the drift: where the centre moves for each pentad you step back, the arrow toward the source, stored as a fraction of the design speed so it can never exceed it. Three are the waist ellipse, and here the storage matters: instead of an angle and two radii, we store the matrix logarithm of the covariance — a symmetric two-by-two matrix whose entries are in log-kilometres. Its trace is the overall size; its traceless part is the log of the aspect ratio times the double-angle phasor, cos two theta and sin two theta. That representation has no angle to wrap around at 180 degrees, treats a circle as the natural zero, and — the point the reviewer raised — is scale-free. Three more numbers are the velocity-spread ellipse, which says how fast the footprint widens per pentad; a footprint whose standard deviation grows linearly with lag is exactly the reach-grows-with-lag rule the geometry module already encodes. Why log form, in one sentence: the Adam optimiser moves every parameter by roughly one learning rate per step in that parameter's own units, so a radius stored in kilometres moves a fixed number of kilometres — which freezes a wide aperture and makes a narrow one jitter — while a log-radius moves by a fixed fraction of its current size, the same at every scale. The future cone is the mirror image with the same covariance, the anchor's own cell is always included, and the one thing this slide leaves out — that channels need different sizes — is the next slide.</a:t>
+              <a:t>Point four, the proposal, in its revision-3 form. The cone at a given lag is a Gaussian footprint: a centre, and a covariance that says how wide it is and in which direction it is stretched. The dots are the fixed sunflower — the same twenty-four-point pattern the project has used since E-026, the experiment that introduced the sunflower stencil for stage two — pushed through that covariance, so the pattern is squashed, stretched and shifted but never re-invented. One small change from earlier revisions, prompted by Chris asking whether time is sampled the same way: it is not a three-dimensional sunflower — time is sampled densely, one slice per pentad, because five days is the finest cadence the tensor has and the thirty-day window is the codec's whole job under cone v2's split — but a stack of identical slices repeats the same bearings at every lag, and consecutive lags sit closer together than the dots do, which is a redundant sampling of the cone's volume. So the sunflower's phase now advances by the golden angle from one lag to the next: the slices interleave, the cone is covered like a three-dimensional Fibonacci lattice, and it costs nothing. Eight numbers per region and channel group define it. Two are the drift: where the centre moves for each pentad you step back, the arrow toward the source, stored as a fraction of the design speed so it can never exceed it. Three are the waist ellipse, and here the storage matters: instead of an angle and two radii, we store the matrix logarithm of the covariance — a symmetric two-by-two matrix whose entries are in log-kilometres. Its trace is the overall size; its traceless part is the log of the aspect ratio times the double-angle phasor, cos two theta and sin two theta. That representation has no angle to wrap around at 180 degrees, treats a circle as the natural zero, and — the point the reviewer raised — is scale-free. Three more numbers are the velocity-spread ellipse, which says how fast the footprint widens per pentad; a footprint whose standard deviation grows linearly with lag is exactly the reach-grows-with-lag rule the geometry module already encodes. Why log form, in one sentence: the Adam optimiser moves every parameter by roughly one learning rate per step in that parameter's own units, so a radius stored in kilometres moves a fixed number of kilometres — which freezes a wide aperture and makes a narrow one jitter — while a log-radius moves by a fixed fraction of its current size, the same at every scale. The future cone is the mirror image with the same covariance, the anchor's own cell is always included, and the one thing this slide leaves out — that channels need different sizes — is the next slide.</a:t>
             </a:r>
             <a:endParaRPr lang="en-US" dirty="0"/>
           </a:p>
@@ -2193,7 +2193,7 @@
           <a:p>
             <a:r>
               <a:rPr lang="en-US" dirty="0"/>
-              <a:t>This slide answers a question Chris asked: don't we need a scale for each channel? Yes — and the split is the whole design. What is shared is the direction: the drift toward the source and the elongation of the footprint along the jet. Those are properties of the flow. Temperature, salinity, sea-surface height and the currents themselves are all carried by the same water, so giving each of them its own arrow would multiply the parameters and let the model learn different "upstreams" for quantities that arrive from the same place. What is per channel is the scale. The current geometry module — the file `ml/cone.py`, whose `FAMILIES` table assigns every channel a propagation speed, a memory and a correlation length — already says the channels differ: wind stress reads five hundred kilometres at the two lags inside its ten-day memory and nothing beyond, the ocean channels grow at a hundred and thirty kilometres per pentad, sea-surface temperature and mixed-layer depth are L-shaped — wide at lags zero and one where the atmosphere stirs them, then the ocean's slow growth — and land is a flat four hundred kilometres because soil does not advect. So each channel gets one number, a log-scale offset, that inflates or shrinks the shared ellipse without turning it; the L-shaped channels get two, one for the first two lags and one beyond. Those offsets start at the values the geometry module already uses, so at step zero every channel reads exactly the reach it reads today. In the picture: the left panel is one dot set with three apertures of different size but the same centre and orientation; the right panel shows the same dots weighted for two channels — for the currents only the inner dots count, for sea-surface temperature at lag one more of them do. How the weighting happens, and why it costs no tokens, is the next slide.</a:t>
+              <a:t>This slide answers a question Chris asked: don't we need a scale for each channel? Yes — and the split is the whole design. What is shared is the direction: the drift toward the source and the elongation of the footprint along the jet. Those are properties of the flow. Temperature, salinity, sea-surface height and the currents themselves are all carried by the same water, so giving each of them its own arrow would multiply the parameters and let the model learn different "upstreams" for quantities that arrive from the same place. What is per channel is the scale. The current geometry module — the file `ml/cone.py`, whose `FAMILIES` table assigns every channel a propagation speed, a memory and a correlation length — already says the channels differ: wind stress reads five hundred kilometres at the two lags inside its ten-day memory and nothing beyond, the ocean channels grow at a hundred and thirty kilometres per pentad, sea-surface temperature and mixed-layer depth are L-shaped — wide at lags zero and one where the atmosphere stirs them, then the ocean's slow growth — and land is a flat four hundred kilometres because soil does not advect. So each channel gets a log-scale offset that inflates or shrinks the shared ellipse without turning it — two of them for the L-shaped channels, one for the first two lags and one beyond — and, since revision 3.1, a memory: a time constant that says how far back the channel is worth reading, applied as an exponential weight over lag. That second number is the same table's other column made learnable: wind stress today is hard-coded to read lags zero and one and nothing beyond, because its memory is ten days; with a learned memory that cut-off is a starting value, not a rule. Both start at the values the geometry module already uses, so at step zero every channel reads exactly the reach and the lags it reads today. In the picture: the left panel is one dot set with three apertures of different size but the same centre and orientation; the right panel shows the same dots weighted for two channels — for the currents only the inner dots count, for sea-surface temperature at lag one more of them do. How the weighting happens, and why it costs no tokens, is the next slide.</a:t>
             </a:r>
             <a:endParaRPr lang="en-US" dirty="0"/>
           </a:p>
@@ -3456,7 +3456,7 @@
                 <a:ea typeface="Calibri" pitchFamily="34" charset="-122"/>
                 <a:cs typeface="Calibri" pitchFamily="34" charset="-120"/>
               </a:rPr>
-              <a:t>c,i</a:t>
+              <a:t>c,i,ℓ</a:t>
             </a:r>
             <a:r>
               <a:rPr lang="en-US" sz="1100" dirty="0">
@@ -3533,7 +3533,29 @@
                 <a:ea typeface="Calibri" pitchFamily="34" charset="-122"/>
                 <a:cs typeface="Calibri" pitchFamily="34" charset="-120"/>
               </a:rPr>
-              <a:t>), and it multiplies that channel's value and observed-flag entries </a:t>
+              <a:t>) · exp(−ℓΔt/τ</a:t>
+            </a:r>
+            <a:r>
+              <a:rPr lang="en-US" sz="1100" baseline="-40000" dirty="0">
+                <a:solidFill>
+                  <a:srgbClr val="E6EDF3"/>
+                </a:solidFill>
+                <a:latin typeface="Calibri" pitchFamily="34" charset="0"/>
+                <a:ea typeface="Calibri" pitchFamily="34" charset="-122"/>
+                <a:cs typeface="Calibri" pitchFamily="34" charset="-120"/>
+              </a:rPr>
+              <a:t>c</a:t>
+            </a:r>
+            <a:r>
+              <a:rPr lang="en-US" sz="1100" dirty="0">
+                <a:solidFill>
+                  <a:srgbClr val="E6EDF3"/>
+                </a:solidFill>
+                <a:latin typeface="Calibri" pitchFamily="34" charset="0"/>
+                <a:ea typeface="Calibri" pitchFamily="34" charset="-122"/>
+                <a:cs typeface="Calibri" pitchFamily="34" charset="-120"/>
+              </a:rPr>
+              <a:t>) — </a:t>
             </a:r>
             <a:r>
               <a:rPr lang="en-US" sz="1100" b="1" dirty="0">
@@ -3544,7 +3566,7 @@
                 <a:ea typeface="Calibri" pitchFamily="34" charset="-122"/>
                 <a:cs typeface="Calibri" pitchFamily="34" charset="-120"/>
               </a:rPr>
-              <a:t>before the projection</a:t>
+              <a:t>a space factor and a time factor</a:t>
             </a:r>
             <a:r>
               <a:rPr lang="en-US" sz="1100" dirty="0">
@@ -3555,7 +3577,29 @@
                 <a:ea typeface="Calibri" pitchFamily="34" charset="-122"/>
                 <a:cs typeface="Calibri" pitchFamily="34" charset="-120"/>
               </a:rPr>
-              <a:t>. A dot outside channel c's aperture contributes ≈ 0 for c and still carries the others at full weight</a:t>
+              <a:t> — and it multiplies that channel's value and observed-flag entries before the projection. A dot outside channel c's aperture in space </a:t>
+            </a:r>
+            <a:r>
+              <a:rPr lang="en-US" sz="1100" i="1" dirty="0">
+                <a:solidFill>
+                  <a:srgbClr val="E3B341"/>
+                </a:solidFill>
+                <a:latin typeface="Calibri" pitchFamily="34" charset="0"/>
+                <a:ea typeface="Calibri" pitchFamily="34" charset="-122"/>
+                <a:cs typeface="Calibri" pitchFamily="34" charset="-120"/>
+              </a:rPr>
+              <a:t>or</a:t>
+            </a:r>
+            <a:r>
+              <a:rPr lang="en-US" sz="1100" dirty="0">
+                <a:solidFill>
+                  <a:srgbClr val="E6EDF3"/>
+                </a:solidFill>
+                <a:latin typeface="Calibri" pitchFamily="34" charset="0"/>
+                <a:ea typeface="Calibri" pitchFamily="34" charset="-122"/>
+                <a:cs typeface="Calibri" pitchFamily="34" charset="-120"/>
+              </a:rPr>
+              <a:t> beyond its memory in time contributes ≈ 0 for c and still carries the others at full weight</a:t>
             </a:r>
             <a:endParaRPr lang="en-US" sz="1100" dirty="0"/>
           </a:p>
@@ -3587,7 +3631,29 @@
                 <a:ea typeface="Calibri" pitchFamily="34" charset="-122"/>
                 <a:cs typeface="Calibri" pitchFamily="34" charset="-120"/>
               </a:rPr>
-              <a:t>, a dot 400 km from the anchor at lag 1, apertures at their initial values: currents σ = 259 km → w = exp(−½·(400/259)²) ≈ 0.30; sea-surface temperature σ = 500 km → w ≈ 0.73. The same token feeds temperature at 73 % and the currents at 30 %</a:t>
+              <a:t>, a dot 400 km from the anchor at lag 1, apertures at their initial values: currents σ = 259 km → w ≈ 0.30; sea-surface temperature σ = 500 km → w ≈ 0.73 (both with a long memory, time factor ≈ 1). For wind stress at lag 4 the time factor alone is e</a:t>
+            </a:r>
+            <a:r>
+              <a:rPr lang="en-US" sz="1100" baseline="30000" dirty="0">
+                <a:solidFill>
+                  <a:srgbClr val="E6EDF3"/>
+                </a:solidFill>
+                <a:latin typeface="Calibri" pitchFamily="34" charset="0"/>
+                <a:ea typeface="Calibri" pitchFamily="34" charset="-122"/>
+                <a:cs typeface="Calibri" pitchFamily="34" charset="-120"/>
+              </a:rPr>
+              <a:t>−20/10</a:t>
+            </a:r>
+            <a:r>
+              <a:rPr lang="en-US" sz="1100" dirty="0">
+                <a:solidFill>
+                  <a:srgbClr val="E6EDF3"/>
+                </a:solidFill>
+                <a:latin typeface="Calibri" pitchFamily="34" charset="0"/>
+                <a:ea typeface="Calibri" pitchFamily="34" charset="-122"/>
+                <a:cs typeface="Calibri" pitchFamily="34" charset="-120"/>
+              </a:rPr>
+              <a:t> ≈ 0.14 — the “lags 0–1 only” rule, as a soft weight</a:t>
             </a:r>
             <a:endParaRPr lang="en-US" sz="1100" dirty="0"/>
           </a:p>
@@ -3608,7 +3674,29 @@
                 <a:ea typeface="Calibri" pitchFamily="34" charset="-122"/>
                 <a:cs typeface="Calibri" pitchFamily="34" charset="-120"/>
               </a:rPr>
-              <a:t>The gradient reaches S, d and s</a:t>
+              <a:t>The gradient reaches S, d, s</a:t>
+            </a:r>
+            <a:r>
+              <a:rPr lang="en-US" sz="1100" b="1" baseline="-40000" dirty="0">
+                <a:solidFill>
+                  <a:srgbClr val="4493F8"/>
+                </a:solidFill>
+                <a:latin typeface="Calibri" pitchFamily="34" charset="0"/>
+                <a:ea typeface="Calibri" pitchFamily="34" charset="-122"/>
+                <a:cs typeface="Calibri" pitchFamily="34" charset="-120"/>
+              </a:rPr>
+              <a:t>c</a:t>
+            </a:r>
+            <a:r>
+              <a:rPr lang="en-US" sz="1100" b="1" dirty="0">
+                <a:solidFill>
+                  <a:srgbClr val="4493F8"/>
+                </a:solidFill>
+                <a:latin typeface="Calibri" pitchFamily="34" charset="0"/>
+                <a:ea typeface="Calibri" pitchFamily="34" charset="-122"/>
+                <a:cs typeface="Calibri" pitchFamily="34" charset="-120"/>
+              </a:rPr>
+              <a:t> and τ</a:t>
             </a:r>
             <a:r>
               <a:rPr lang="en-US" sz="1100" b="1" baseline="-40000" dirty="0">
@@ -5121,7 +5209,7 @@
                 <a:ea typeface="Calibri" pitchFamily="34" charset="-122"/>
                 <a:cs typeface="Calibri" pitchFamily="34" charset="-120"/>
               </a:rPr>
-              <a:t>64,800 cells × 3 groups × 8 numbers, about half of it live (ocean maps over ocean, land maps over land), plus ~50 global per-channel scale offsets (slide 9) — cheap, and no compute</a:t>
+              <a:t>64,800 cells × 3 groups × 8 numbers, about half of it live (ocean maps over ocean, land maps over land), plus a scale s_c and a memory τ_c per channel (~100 numbers, global — slide 9) — cheap, and no compute</a:t>
             </a:r>
             <a:endParaRPr lang="en-US" sz="3000" dirty="0"/>
           </a:p>
@@ -5547,7 +5635,29 @@
                 <a:ea typeface="Calibri" pitchFamily="34" charset="-122"/>
                 <a:cs typeface="Calibri" pitchFamily="34" charset="-120"/>
               </a:rPr>
-              <a:t> and s</a:t>
+              <a:t>, s</a:t>
+            </a:r>
+            <a:r>
+              <a:rPr lang="en-US" sz="1050" baseline="-40000" dirty="0">
+                <a:solidFill>
+                  <a:srgbClr val="E6EDF3"/>
+                </a:solidFill>
+                <a:latin typeface="Calibri" pitchFamily="34" charset="0"/>
+                <a:ea typeface="Calibri" pitchFamily="34" charset="-122"/>
+                <a:cs typeface="Calibri" pitchFamily="34" charset="-120"/>
+              </a:rPr>
+              <a:t>c</a:t>
+            </a:r>
+            <a:r>
+              <a:rPr lang="en-US" sz="1050" dirty="0">
+                <a:solidFill>
+                  <a:srgbClr val="E6EDF3"/>
+                </a:solidFill>
+                <a:latin typeface="Calibri" pitchFamily="34" charset="0"/>
+                <a:ea typeface="Calibri" pitchFamily="34" charset="-122"/>
+                <a:cs typeface="Calibri" pitchFamily="34" charset="-120"/>
+              </a:rPr>
+              <a:t> and τ</a:t>
             </a:r>
             <a:r>
               <a:rPr lang="en-US" sz="1050" baseline="-40000" dirty="0">
@@ -6157,6 +6267,28 @@
                 <a:cs typeface="Calibri" pitchFamily="34" charset="-120"/>
               </a:rPr>
               <a:t>; s</a:t>
+            </a:r>
+            <a:r>
+              <a:rPr lang="en-US" sz="1100" baseline="-40000" dirty="0">
+                <a:solidFill>
+                  <a:srgbClr val="E6EDF3"/>
+                </a:solidFill>
+                <a:latin typeface="Calibri" pitchFamily="34" charset="0"/>
+                <a:ea typeface="Calibri" pitchFamily="34" charset="-122"/>
+                <a:cs typeface="Calibri" pitchFamily="34" charset="-120"/>
+              </a:rPr>
+              <a:t>c</a:t>
+            </a:r>
+            <a:r>
+              <a:rPr lang="en-US" sz="1100" dirty="0">
+                <a:solidFill>
+                  <a:srgbClr val="E6EDF3"/>
+                </a:solidFill>
+                <a:latin typeface="Calibri" pitchFamily="34" charset="0"/>
+                <a:ea typeface="Calibri" pitchFamily="34" charset="-122"/>
+                <a:cs typeface="Calibri" pitchFamily="34" charset="-120"/>
+              </a:rPr>
+              <a:t> and τ</a:t>
             </a:r>
             <a:r>
               <a:rPr lang="en-US" sz="1100" baseline="-40000" dirty="0">
@@ -10187,7 +10319,7 @@
                 <a:ea typeface="Calibri" pitchFamily="34" charset="-122"/>
                 <a:cs typeface="Calibri" pitchFamily="34" charset="-120"/>
               </a:rPr>
-              <a:t>waist_dots, future_dots = reflected inner_dots; coverage_report extended with the mirror identity (future set = −past set) — pure numpy, CPU test</a:t>
+              <a:t>waist_dots, future_dots = reflected inner_dots, the per-lag golden-angle phase in inner_dots; coverage_report extended with the mirror identity (future set = −past set) and re-asserted per lag under the phase — pure numpy, CPU test</a:t>
             </a:r>
             <a:endParaRPr lang="en-US" sz="1150" dirty="0"/>
           </a:p>
@@ -10469,7 +10601,7 @@
                 <a:ea typeface="Calibri" pitchFamily="34" charset="-122"/>
                 <a:cs typeface="Calibri" pitchFamily="34" charset="-120"/>
               </a:rPr>
-              <a:t>per-channel weights w_{c,i} on the per-location candidate tokens, ring ungated; test: with every s_c → +∞ the forward pass equals the ungated model bit-for-bit, and the finite-difference gradient of the loss w.r.t. S₀, Σ_v, d, s_c matches autograd</a:t>
+              <a:t>per-channel space-time weights w_{c,i,ℓ} on the per-location candidate tokens, ring ungated; test: with every s_c → +∞ and τ_c → +∞ the forward pass equals the ungated model bit-for-bit, and the finite-difference gradient of the loss w.r.t. S₀, Σ_v, d, s_c, τ_c matches autograd</a:t>
             </a:r>
             <a:endParaRPr lang="en-US" sz="1150" dirty="0"/>
           </a:p>
@@ -10892,7 +11024,7 @@
               <a:buNone/>
             </a:pPr>
             <a:r>
-              <a:rPr lang="en-US" sz="2900" b="1" dirty="0">
+              <a:rPr lang="en-US" sz="2800" b="1" dirty="0">
                 <a:solidFill>
                   <a:srgbClr val="E6EDF3"/>
                 </a:solidFill>
@@ -10900,9 +11032,9 @@
                 <a:ea typeface="Georgia" pitchFamily="34" charset="-122"/>
                 <a:cs typeface="Georgia" pitchFamily="34" charset="-120"/>
               </a:rPr>
-              <a:t>Two settled, six still open — all reversible</a:t>
-            </a:r>
-            <a:endParaRPr lang="en-US" sz="2900" dirty="0"/>
+              <a:t>Two settled, seven still open — all reversible</a:t>
+            </a:r>
+            <a:endParaRPr lang="en-US" sz="2800" dirty="0"/>
           </a:p>
         </p:txBody>
       </p:sp>
@@ -11103,7 +11235,7 @@
         <p:spPr>
           <a:xfrm>
             <a:off x="548640" y="2432304"/>
-            <a:ext cx="3557016" cy="1755648"/>
+            <a:ext cx="2621585" cy="1755648"/>
           </a:xfrm>
           <a:prstGeom prst="roundRect">
             <a:avLst>
@@ -11130,7 +11262,7 @@
         <p:spPr>
           <a:xfrm>
             <a:off x="786384" y="2578608"/>
-            <a:ext cx="3081528" cy="1463040"/>
+            <a:ext cx="2146097" cy="1463040"/>
           </a:xfrm>
           <a:prstGeom prst="rect">
             <a:avLst/>
@@ -11166,7 +11298,7 @@
               <a:buNone/>
             </a:pPr>
             <a:r>
-              <a:rPr lang="en-US" sz="1100" b="1" dirty="0">
+              <a:rPr lang="en-US" sz="1050" b="1" dirty="0">
                 <a:solidFill>
                   <a:srgbClr val="4493F8"/>
                 </a:solidFill>
@@ -11177,7 +11309,7 @@
               <a:t>+6 pentads</a:t>
             </a:r>
             <a:r>
-              <a:rPr lang="en-US" sz="1100" dirty="0">
+              <a:rPr lang="en-US" sz="1050" dirty="0">
                 <a:solidFill>
                   <a:srgbClr val="E6EDF3"/>
                 </a:solidFill>
@@ -11199,8 +11331,8 @@
         </p:nvSpPr>
         <p:spPr>
           <a:xfrm>
-            <a:off x="4315968" y="2432304"/>
-            <a:ext cx="3557016" cy="1755648"/>
+            <a:off x="3371393" y="2432304"/>
+            <a:ext cx="2621585" cy="1755648"/>
           </a:xfrm>
           <a:prstGeom prst="roundRect">
             <a:avLst>
@@ -11226,8 +11358,8 @@
         </p:nvSpPr>
         <p:spPr>
           <a:xfrm>
-            <a:off x="4553712" y="2578608"/>
-            <a:ext cx="3081528" cy="1463040"/>
+            <a:off x="3609137" y="2578608"/>
+            <a:ext cx="2146097" cy="1463040"/>
           </a:xfrm>
           <a:prstGeom prst="rect">
             <a:avLst/>
@@ -11263,7 +11395,7 @@
               <a:buNone/>
             </a:pPr>
             <a:r>
-              <a:rPr lang="en-US" sz="1100" b="1" dirty="0">
+              <a:rPr lang="en-US" sz="1050" b="1" dirty="0">
                 <a:solidFill>
                   <a:srgbClr val="4493F8"/>
                 </a:solidFill>
@@ -11274,7 +11406,7 @@
               <a:t>0.35 / 0.15 / 0.25 / 0.25</a:t>
             </a:r>
             <a:r>
-              <a:rPr lang="en-US" sz="1100" dirty="0">
+              <a:rPr lang="en-US" sz="1050" dirty="0">
                 <a:solidFill>
                   <a:srgbClr val="E6EDF3"/>
                 </a:solidFill>
@@ -11296,8 +11428,8 @@
         </p:nvSpPr>
         <p:spPr>
           <a:xfrm>
-            <a:off x="8083296" y="2432304"/>
-            <a:ext cx="3557016" cy="1755648"/>
+            <a:off x="6194146" y="2432304"/>
+            <a:ext cx="2621585" cy="1755648"/>
           </a:xfrm>
           <a:prstGeom prst="roundRect">
             <a:avLst>
@@ -11323,8 +11455,8 @@
         </p:nvSpPr>
         <p:spPr>
           <a:xfrm>
-            <a:off x="8321040" y="2578608"/>
-            <a:ext cx="3081528" cy="1463040"/>
+            <a:off x="6431890" y="2578608"/>
+            <a:ext cx="2146097" cy="1463040"/>
           </a:xfrm>
           <a:prstGeom prst="rect">
             <a:avLst/>
@@ -11360,7 +11492,7 @@
               <a:buNone/>
             </a:pPr>
             <a:r>
-              <a:rPr lang="en-US" sz="1100" dirty="0">
+              <a:rPr lang="en-US" sz="1050" dirty="0">
                 <a:solidFill>
                   <a:srgbClr val="E6EDF3"/>
                 </a:solidFill>
@@ -11382,8 +11514,8 @@
         </p:nvSpPr>
         <p:spPr>
           <a:xfrm>
-            <a:off x="548640" y="4334256"/>
-            <a:ext cx="3557016" cy="1755648"/>
+            <a:off x="9016898" y="2432304"/>
+            <a:ext cx="2621585" cy="1755648"/>
           </a:xfrm>
           <a:prstGeom prst="roundRect">
             <a:avLst>
@@ -11409,8 +11541,8 @@
         </p:nvSpPr>
         <p:spPr>
           <a:xfrm>
-            <a:off x="786384" y="4480560"/>
-            <a:ext cx="3081528" cy="1463040"/>
+            <a:off x="9254642" y="2578608"/>
+            <a:ext cx="2146097" cy="1463040"/>
           </a:xfrm>
           <a:prstGeom prst="rect">
             <a:avLst/>
@@ -11446,7 +11578,7 @@
               <a:buNone/>
             </a:pPr>
             <a:r>
-              <a:rPr lang="en-US" sz="1100" b="1" dirty="0">
+              <a:rPr lang="en-US" sz="1050" b="1" dirty="0">
                 <a:solidFill>
                   <a:srgbClr val="4493F8"/>
                 </a:solidFill>
@@ -11457,7 +11589,7 @@
               <a:t>Kept</a:t>
             </a:r>
             <a:r>
-              <a:rPr lang="en-US" sz="1100" dirty="0">
+              <a:rPr lang="en-US" sz="1050" dirty="0">
                 <a:solidFill>
                   <a:srgbClr val="E6EDF3"/>
                 </a:solidFill>
@@ -11479,7 +11611,7 @@
         </p:nvSpPr>
         <p:spPr>
           <a:xfrm>
-            <a:off x="4315968" y="4334256"/>
+            <a:off x="548640" y="4334256"/>
             <a:ext cx="3557016" cy="1755648"/>
           </a:xfrm>
           <a:prstGeom prst="roundRect">
@@ -11506,7 +11638,7 @@
         </p:nvSpPr>
         <p:spPr>
           <a:xfrm>
-            <a:off x="4553712" y="4480560"/>
+            <a:off x="786384" y="4480560"/>
             <a:ext cx="3081528" cy="1463040"/>
           </a:xfrm>
           <a:prstGeom prst="rect">
@@ -11576,7 +11708,7 @@
         </p:nvSpPr>
         <p:spPr>
           <a:xfrm>
-            <a:off x="8083296" y="4334256"/>
+            <a:off x="4315968" y="4334256"/>
             <a:ext cx="3557016" cy="1755648"/>
           </a:xfrm>
           <a:prstGeom prst="roundRect">
@@ -11603,7 +11735,7 @@
         </p:nvSpPr>
         <p:spPr>
           <a:xfrm>
-            <a:off x="8321040" y="4480560"/>
+            <a:off x="4553712" y="4480560"/>
             <a:ext cx="3081528" cy="1463040"/>
           </a:xfrm>
           <a:prstGeom prst="rect">
@@ -11682,6 +11814,125 @@
                 <a:cs typeface="Calibri" pitchFamily="34" charset="-120"/>
               </a:rPr>
               <a:t> — first guesses, both recorded per run</a:t>
+            </a:r>
+            <a:endParaRPr lang="en-US" sz="1250" dirty="0"/>
+          </a:p>
+        </p:txBody>
+      </p:sp>
+      <p:sp>
+        <p:nvSpPr>
+          <p:cNvPr id="21" name="Shape 18"/>
+          <p:cNvSpPr/>
+          <p:nvPr/>
+        </p:nvSpPr>
+        <p:spPr>
+          <a:xfrm>
+            <a:off x="8083296" y="4334256"/>
+            <a:ext cx="3557016" cy="1755648"/>
+          </a:xfrm>
+          <a:prstGeom prst="roundRect">
+            <a:avLst>
+              <a:gd name="adj" fmla="val 3125"/>
+            </a:avLst>
+          </a:prstGeom>
+          <a:solidFill>
+            <a:srgbClr val="161B22"/>
+          </a:solidFill>
+          <a:ln w="12700">
+            <a:solidFill>
+              <a:srgbClr val="30363D"/>
+            </a:solidFill>
+            <a:prstDash val="solid"/>
+          </a:ln>
+        </p:spPr>
+      </p:sp>
+      <p:sp>
+        <p:nvSpPr>
+          <p:cNvPr id="22" name="Text 19"/>
+          <p:cNvSpPr txBox="1"/>
+          <p:nvPr/>
+        </p:nvSpPr>
+        <p:spPr>
+          <a:xfrm>
+            <a:off x="8321040" y="4480560"/>
+            <a:ext cx="3081528" cy="1463040"/>
+          </a:xfrm>
+          <a:prstGeom prst="rect">
+            <a:avLst/>
+          </a:prstGeom>
+          <a:noFill/>
+          <a:ln/>
+        </p:spPr>
+        <p:txBody>
+          <a:bodyPr wrap="square" lIns="0" tIns="0" rIns="0" bIns="0" rtlCol="0" anchor="ctr"/>
+          <a:lstStyle/>
+          <a:p>
+            <a:pPr indent="0" marL="0">
+              <a:spcAft>
+                <a:spcPts val="800"/>
+              </a:spcAft>
+              <a:buNone/>
+            </a:pPr>
+            <a:r>
+              <a:rPr lang="en-US" sz="1250" b="1" dirty="0">
+                <a:solidFill>
+                  <a:srgbClr val="4493F8"/>
+                </a:solidFill>
+                <a:latin typeface="Calibri" pitchFamily="34" charset="0"/>
+                <a:ea typeface="Calibri" pitchFamily="34" charset="-122"/>
+                <a:cs typeface="Calibri" pitchFamily="34" charset="-120"/>
+              </a:rPr>
+              <a:t>Time inside the 30-day window</a:t>
+            </a:r>
+            <a:endParaRPr lang="en-US" sz="1250" dirty="0"/>
+          </a:p>
+          <a:p>
+            <a:pPr indent="0" marL="0">
+              <a:buNone/>
+            </a:pPr>
+            <a:r>
+              <a:rPr lang="en-US" sz="1100" b="1" dirty="0">
+                <a:solidFill>
+                  <a:srgbClr val="4493F8"/>
+                </a:solidFill>
+                <a:latin typeface="Calibri" pitchFamily="34" charset="0"/>
+                <a:ea typeface="Calibri" pitchFamily="34" charset="-122"/>
+                <a:cs typeface="Calibri" pitchFamily="34" charset="-120"/>
+              </a:rPr>
+              <a:t>Dense</a:t>
+            </a:r>
+            <a:r>
+              <a:rPr lang="en-US" sz="1100" dirty="0">
+                <a:solidFill>
+                  <a:srgbClr val="E6EDF3"/>
+                </a:solidFill>
+                <a:latin typeface="Calibri" pitchFamily="34" charset="0"/>
+                <a:ea typeface="Calibri" pitchFamily="34" charset="-122"/>
+                <a:cs typeface="Calibri" pitchFamily="34" charset="-120"/>
+              </a:rPr>
+              <a:t>, one slice per pentad. A log-spaced inner time ramp (1, 2, 3, 5, 8, 13 pentads at the same six slices) is an </a:t>
+            </a:r>
+            <a:r>
+              <a:rPr lang="en-US" sz="1100" b="1" dirty="0">
+                <a:solidFill>
+                  <a:srgbClr val="4493F8"/>
+                </a:solidFill>
+                <a:latin typeface="Calibri" pitchFamily="34" charset="0"/>
+                <a:ea typeface="Calibri" pitchFamily="34" charset="-122"/>
+                <a:cs typeface="Calibri" pitchFamily="34" charset="-120"/>
+              </a:rPr>
+              <a:t>ablation</a:t>
+            </a:r>
+            <a:r>
+              <a:rPr lang="en-US" sz="1100" dirty="0">
+                <a:solidFill>
+                  <a:srgbClr val="E6EDF3"/>
+                </a:solidFill>
+                <a:latin typeface="Calibri" pitchFamily="34" charset="0"/>
+                <a:ea typeface="Calibri" pitchFamily="34" charset="-122"/>
+                <a:cs typeface="Calibri" pitchFamily="34" charset="-120"/>
+              </a:rPr>
+              <a:t>, not the design — it would move the codec's window into stage 2's</a:t>
             </a:r>
             <a:endParaRPr lang="en-US" sz="1250" dirty="0"/>
           </a:p>
@@ -18155,8 +18406,8 @@
         </p:blipFill>
         <p:spPr>
           <a:xfrm>
-            <a:off x="1069848" y="1371600"/>
-            <a:ext cx="10058400" cy="2386584"/>
+            <a:off x="1179576" y="1316736"/>
+            <a:ext cx="9829800" cy="2331720"/>
           </a:xfrm>
           <a:prstGeom prst="rect">
             <a:avLst/>
@@ -18171,12 +18422,12 @@
         </p:nvSpPr>
         <p:spPr>
           <a:xfrm>
-            <a:off x="548640" y="3840480"/>
-            <a:ext cx="11091672" cy="804672"/>
+            <a:off x="548640" y="3721608"/>
+            <a:ext cx="11091672" cy="731520"/>
           </a:xfrm>
           <a:prstGeom prst="roundRect">
             <a:avLst>
-              <a:gd name="adj" fmla="val 6818"/>
+              <a:gd name="adj" fmla="val 7500"/>
             </a:avLst>
           </a:prstGeom>
           <a:solidFill>
@@ -18198,8 +18449,8 @@
         </p:nvSpPr>
         <p:spPr>
           <a:xfrm>
-            <a:off x="822960" y="3913632"/>
-            <a:ext cx="10543032" cy="237744"/>
+            <a:off x="822960" y="3794760"/>
+            <a:ext cx="10543032" cy="219456"/>
           </a:xfrm>
           <a:prstGeom prst="rect">
             <a:avLst/>
@@ -18237,8 +18488,8 @@
         </p:nvSpPr>
         <p:spPr>
           <a:xfrm>
-            <a:off x="822960" y="4169664"/>
-            <a:ext cx="10543032" cy="384048"/>
+            <a:off x="822960" y="4032504"/>
+            <a:ext cx="10543032" cy="365760"/>
           </a:xfrm>
           <a:prstGeom prst="rect">
             <a:avLst/>
@@ -18397,8 +18648,8 @@
         </p:nvSpPr>
         <p:spPr>
           <a:xfrm>
-            <a:off x="548640" y="4718304"/>
-            <a:ext cx="5440680" cy="1499616"/>
+            <a:off x="548640" y="4526280"/>
+            <a:ext cx="5440680" cy="1691640"/>
           </a:xfrm>
           <a:prstGeom prst="rect">
             <a:avLst/>
@@ -18477,7 +18728,7 @@
                 <a:ea typeface="Calibri" pitchFamily="34" charset="-122"/>
                 <a:cs typeface="Calibri" pitchFamily="34" charset="-120"/>
               </a:rPr>
-              <a:t>), fixed, 24 points, the same at every lag</a:t>
+              <a:t>), fixed, 24 points</a:t>
             </a:r>
             <a:endParaRPr lang="en-US" sz="1000" dirty="0"/>
           </a:p>
@@ -18498,7 +18749,7 @@
                 <a:ea typeface="Calibri" pitchFamily="34" charset="-122"/>
                 <a:cs typeface="Calibri" pitchFamily="34" charset="-120"/>
               </a:rPr>
-              <a:t>d</a:t>
+              <a:t>Phase-rotated by the golden angle per lag</a:t>
             </a:r>
             <a:r>
               <a:rPr lang="en-US" sz="1000" dirty="0">
@@ -18509,18 +18760,18 @@
                 <a:ea typeface="Calibri" pitchFamily="34" charset="-122"/>
                 <a:cs typeface="Calibri" pitchFamily="34" charset="-120"/>
               </a:rPr>
-              <a:t> (2 numbers): the drift per pentad — where the footprint's centre moves for each pentad back in time; </a:t>
-            </a:r>
-            <a:r>
-              <a:rPr lang="en-US" sz="1000" b="1" dirty="0">
-                <a:solidFill>
-                  <a:srgbClr val="4493F8"/>
-                </a:solidFill>
-                <a:latin typeface="Calibri" pitchFamily="34" charset="0"/>
-                <a:ea typeface="Calibri" pitchFamily="34" charset="-122"/>
-                <a:cs typeface="Calibri" pitchFamily="34" charset="-120"/>
-              </a:rPr>
-              <a:t>the arrow toward the source</a:t>
+              <a:t>: bearing</a:t>
+            </a:r>
+            <a:r>
+              <a:rPr lang="en-US" sz="1000" baseline="-40000" dirty="0">
+                <a:solidFill>
+                  <a:srgbClr val="E6EDF3"/>
+                </a:solidFill>
+                <a:latin typeface="Calibri" pitchFamily="34" charset="0"/>
+                <a:ea typeface="Calibri" pitchFamily="34" charset="-122"/>
+                <a:cs typeface="Calibri" pitchFamily="34" charset="-120"/>
+              </a:rPr>
+              <a:t>i,ℓ</a:t>
             </a:r>
             <a:r>
               <a:rPr lang="en-US" sz="1000" dirty="0">
@@ -18531,7 +18782,7 @@
                 <a:ea typeface="Calibri" pitchFamily="34" charset="-122"/>
                 <a:cs typeface="Calibri" pitchFamily="34" charset="-120"/>
               </a:rPr>
-              <a:t>. Stored dimensionless: d = tanh(x) · v_design·Δt</a:t>
+              <a:t> = i·137.5° + ℓ·137.5°, so the six slices interleave in space-time instead of repeating the same bearings</a:t>
             </a:r>
             <a:endParaRPr lang="en-US" sz="1000" dirty="0"/>
           </a:p>
@@ -18552,10 +18803,31 @@
                 <a:ea typeface="Calibri" pitchFamily="34" charset="-122"/>
                 <a:cs typeface="Calibri" pitchFamily="34" charset="-120"/>
               </a:rPr>
-              <a:t>Σ</a:t>
-            </a:r>
-            <a:r>
-              <a:rPr lang="en-US" sz="1000" b="1" baseline="-40000" dirty="0">
+              <a:t>Time itself stays dense</a:t>
+            </a:r>
+            <a:r>
+              <a:rPr lang="en-US" sz="1000" dirty="0">
+                <a:solidFill>
+                  <a:srgbClr val="E6EDF3"/>
+                </a:solidFill>
+                <a:latin typeface="Calibri" pitchFamily="34" charset="0"/>
+                <a:ea typeface="Calibri" pitchFamily="34" charset="-122"/>
+                <a:cs typeface="Calibri" pitchFamily="34" charset="-120"/>
+              </a:rPr>
+              <a:t>: one slice per pentad — the finest cadence we have, and the 30-day window is the codec's whole job</a:t>
+            </a:r>
+            <a:endParaRPr lang="en-US" sz="1000" dirty="0"/>
+          </a:p>
+          <a:p>
+            <a:pPr marL="203200" indent="-203200">
+              <a:spcAft>
+                <a:spcPts val="600"/>
+              </a:spcAft>
+              <a:buSzPct val="100000"/>
+              <a:buChar char="•"/>
+            </a:pPr>
+            <a:r>
+              <a:rPr lang="en-US" sz="1000" b="1" dirty="0">
                 <a:solidFill>
                   <a:srgbClr val="4493F8"/>
                 </a:solidFill>
@@ -18563,7 +18835,7 @@
                 <a:ea typeface="Calibri" pitchFamily="34" charset="-122"/>
                 <a:cs typeface="Calibri" pitchFamily="34" charset="-120"/>
               </a:rPr>
-              <a:t>0</a:t>
+              <a:t>d</a:t>
             </a:r>
             <a:r>
               <a:rPr lang="en-US" sz="1000" dirty="0">
@@ -18574,7 +18846,7 @@
                 <a:ea typeface="Calibri" pitchFamily="34" charset="-122"/>
                 <a:cs typeface="Calibri" pitchFamily="34" charset="-120"/>
               </a:rPr>
-              <a:t> (3): the waist ellipse, stored as its </a:t>
+              <a:t> (2 numbers): the drift per pentad — where the footprint's centre moves for each pentad back in time; </a:t>
             </a:r>
             <a:r>
               <a:rPr lang="en-US" sz="1000" b="1" dirty="0">
@@ -18585,7 +18857,7 @@
                 <a:ea typeface="Calibri" pitchFamily="34" charset="-122"/>
                 <a:cs typeface="Calibri" pitchFamily="34" charset="-120"/>
               </a:rPr>
-              <a:t>matrix logarithm</a:t>
+              <a:t>the arrow toward the source</a:t>
             </a:r>
             <a:r>
               <a:rPr lang="en-US" sz="1000" dirty="0">
@@ -18596,51 +18868,7 @@
                 <a:ea typeface="Calibri" pitchFamily="34" charset="-122"/>
                 <a:cs typeface="Calibri" pitchFamily="34" charset="-120"/>
               </a:rPr>
-              <a:t> S</a:t>
-            </a:r>
-            <a:r>
-              <a:rPr lang="en-US" sz="1000" baseline="-40000" dirty="0">
-                <a:solidFill>
-                  <a:srgbClr val="E6EDF3"/>
-                </a:solidFill>
-                <a:latin typeface="Calibri" pitchFamily="34" charset="0"/>
-                <a:ea typeface="Calibri" pitchFamily="34" charset="-122"/>
-                <a:cs typeface="Calibri" pitchFamily="34" charset="-120"/>
-              </a:rPr>
-              <a:t>0</a:t>
-            </a:r>
-            <a:r>
-              <a:rPr lang="en-US" sz="1000" dirty="0">
-                <a:solidFill>
-                  <a:srgbClr val="E6EDF3"/>
-                </a:solidFill>
-                <a:latin typeface="Calibri" pitchFamily="34" charset="0"/>
-                <a:ea typeface="Calibri" pitchFamily="34" charset="-122"/>
-                <a:cs typeface="Calibri" pitchFamily="34" charset="-120"/>
-              </a:rPr>
-              <a:t> = log Σ</a:t>
-            </a:r>
-            <a:r>
-              <a:rPr lang="en-US" sz="1000" baseline="-40000" dirty="0">
-                <a:solidFill>
-                  <a:srgbClr val="E6EDF3"/>
-                </a:solidFill>
-                <a:latin typeface="Calibri" pitchFamily="34" charset="0"/>
-                <a:ea typeface="Calibri" pitchFamily="34" charset="-122"/>
-                <a:cs typeface="Calibri" pitchFamily="34" charset="-120"/>
-              </a:rPr>
-              <a:t>0</a:t>
-            </a:r>
-            <a:r>
-              <a:rPr lang="en-US" sz="1000" dirty="0">
-                <a:solidFill>
-                  <a:srgbClr val="E6EDF3"/>
-                </a:solidFill>
-                <a:latin typeface="Calibri" pitchFamily="34" charset="0"/>
-                <a:ea typeface="Calibri" pitchFamily="34" charset="-122"/>
-                <a:cs typeface="Calibri" pitchFamily="34" charset="-120"/>
-              </a:rPr>
-              <a:t> — a symmetric 2×2 whose entries are in log-km. Its trace is the size; its traceless part is (log aspect ratio) × (cos 2θ, sin 2θ). No angle, no 180° wrap; a circle is S = m·I</a:t>
+              <a:t>. Stored dimensionless: d = tanh(x) · v_design·Δt</a:t>
             </a:r>
             <a:endParaRPr lang="en-US" sz="1000" dirty="0"/>
           </a:p>
@@ -18654,8 +18882,8 @@
         </p:nvSpPr>
         <p:spPr>
           <a:xfrm>
-            <a:off x="6199632" y="4718304"/>
-            <a:ext cx="5440680" cy="1499616"/>
+            <a:off x="6199632" y="4526280"/>
+            <a:ext cx="5440680" cy="1691640"/>
           </a:xfrm>
           <a:prstGeom prst="rect">
             <a:avLst/>
@@ -18666,6 +18894,115 @@
         <p:txBody>
           <a:bodyPr wrap="square" lIns="0" tIns="0" rIns="0" bIns="0" rtlCol="0" anchor="t"/>
           <a:lstStyle/>
+          <a:p>
+            <a:pPr marL="203200" indent="-203200">
+              <a:spcAft>
+                <a:spcPts val="600"/>
+              </a:spcAft>
+              <a:buSzPct val="100000"/>
+              <a:buChar char="•"/>
+            </a:pPr>
+            <a:r>
+              <a:rPr lang="en-US" sz="1000" b="1" dirty="0">
+                <a:solidFill>
+                  <a:srgbClr val="4493F8"/>
+                </a:solidFill>
+                <a:latin typeface="Calibri" pitchFamily="34" charset="0"/>
+                <a:ea typeface="Calibri" pitchFamily="34" charset="-122"/>
+                <a:cs typeface="Calibri" pitchFamily="34" charset="-120"/>
+              </a:rPr>
+              <a:t>Σ</a:t>
+            </a:r>
+            <a:r>
+              <a:rPr lang="en-US" sz="1000" b="1" baseline="-40000" dirty="0">
+                <a:solidFill>
+                  <a:srgbClr val="4493F8"/>
+                </a:solidFill>
+                <a:latin typeface="Calibri" pitchFamily="34" charset="0"/>
+                <a:ea typeface="Calibri" pitchFamily="34" charset="-122"/>
+                <a:cs typeface="Calibri" pitchFamily="34" charset="-120"/>
+              </a:rPr>
+              <a:t>0</a:t>
+            </a:r>
+            <a:r>
+              <a:rPr lang="en-US" sz="1000" dirty="0">
+                <a:solidFill>
+                  <a:srgbClr val="E6EDF3"/>
+                </a:solidFill>
+                <a:latin typeface="Calibri" pitchFamily="34" charset="0"/>
+                <a:ea typeface="Calibri" pitchFamily="34" charset="-122"/>
+                <a:cs typeface="Calibri" pitchFamily="34" charset="-120"/>
+              </a:rPr>
+              <a:t> (3): the waist ellipse, stored as its </a:t>
+            </a:r>
+            <a:r>
+              <a:rPr lang="en-US" sz="1000" b="1" dirty="0">
+                <a:solidFill>
+                  <a:srgbClr val="4493F8"/>
+                </a:solidFill>
+                <a:latin typeface="Calibri" pitchFamily="34" charset="0"/>
+                <a:ea typeface="Calibri" pitchFamily="34" charset="-122"/>
+                <a:cs typeface="Calibri" pitchFamily="34" charset="-120"/>
+              </a:rPr>
+              <a:t>matrix logarithm</a:t>
+            </a:r>
+            <a:r>
+              <a:rPr lang="en-US" sz="1000" dirty="0">
+                <a:solidFill>
+                  <a:srgbClr val="E6EDF3"/>
+                </a:solidFill>
+                <a:latin typeface="Calibri" pitchFamily="34" charset="0"/>
+                <a:ea typeface="Calibri" pitchFamily="34" charset="-122"/>
+                <a:cs typeface="Calibri" pitchFamily="34" charset="-120"/>
+              </a:rPr>
+              <a:t> S</a:t>
+            </a:r>
+            <a:r>
+              <a:rPr lang="en-US" sz="1000" baseline="-40000" dirty="0">
+                <a:solidFill>
+                  <a:srgbClr val="E6EDF3"/>
+                </a:solidFill>
+                <a:latin typeface="Calibri" pitchFamily="34" charset="0"/>
+                <a:ea typeface="Calibri" pitchFamily="34" charset="-122"/>
+                <a:cs typeface="Calibri" pitchFamily="34" charset="-120"/>
+              </a:rPr>
+              <a:t>0</a:t>
+            </a:r>
+            <a:r>
+              <a:rPr lang="en-US" sz="1000" dirty="0">
+                <a:solidFill>
+                  <a:srgbClr val="E6EDF3"/>
+                </a:solidFill>
+                <a:latin typeface="Calibri" pitchFamily="34" charset="0"/>
+                <a:ea typeface="Calibri" pitchFamily="34" charset="-122"/>
+                <a:cs typeface="Calibri" pitchFamily="34" charset="-120"/>
+              </a:rPr>
+              <a:t> = log Σ</a:t>
+            </a:r>
+            <a:r>
+              <a:rPr lang="en-US" sz="1000" baseline="-40000" dirty="0">
+                <a:solidFill>
+                  <a:srgbClr val="E6EDF3"/>
+                </a:solidFill>
+                <a:latin typeface="Calibri" pitchFamily="34" charset="0"/>
+                <a:ea typeface="Calibri" pitchFamily="34" charset="-122"/>
+                <a:cs typeface="Calibri" pitchFamily="34" charset="-120"/>
+              </a:rPr>
+              <a:t>0</a:t>
+            </a:r>
+            <a:r>
+              <a:rPr lang="en-US" sz="1000" dirty="0">
+                <a:solidFill>
+                  <a:srgbClr val="E6EDF3"/>
+                </a:solidFill>
+                <a:latin typeface="Calibri" pitchFamily="34" charset="0"/>
+                <a:ea typeface="Calibri" pitchFamily="34" charset="-122"/>
+                <a:cs typeface="Calibri" pitchFamily="34" charset="-120"/>
+              </a:rPr>
+              <a:t> — a symmetric 2×2 in log-km. Its trace is the size; its traceless part is (log aspect ratio) × (cos 2θ, sin 2θ); no 180° wrap, and a circle is S = m·I</a:t>
+            </a:r>
+            <a:endParaRPr lang="en-US" sz="1000" dirty="0"/>
+          </a:p>
           <a:p>
             <a:pPr marL="203200" indent="-203200">
               <a:spcAft>
@@ -18810,7 +19147,7 @@
                 <a:ea typeface="Calibri" pitchFamily="34" charset="-122"/>
                 <a:cs typeface="Calibri" pitchFamily="34" charset="-120"/>
               </a:rPr>
-              <a:t> — the same behaviour at any size</a:t>
+              <a:t> — the same at any size</a:t>
             </a:r>
             <a:endParaRPr lang="en-US" sz="1000" dirty="0"/>
           </a:p>
@@ -18842,7 +19179,7 @@
                 <a:ea typeface="Calibri" pitchFamily="34" charset="-122"/>
                 <a:cs typeface="Calibri" pitchFamily="34" charset="-120"/>
               </a:rPr>
-              <a:t> reflected — centre −ℓ·d, the same Σ(ℓ); the anchor column (0, 0) is always added. The per-channel scale is the next slide</a:t>
+              <a:t> reflected — centre −ℓ·d, the same Σ(ℓ); the anchor column (0, 0) is always added. Per-channel scale and memory: next slide</a:t>
             </a:r>
             <a:endParaRPr lang="en-US" sz="1000" dirty="0"/>
           </a:p>
@@ -19052,8 +19389,8 @@
         </p:blipFill>
         <p:spPr>
           <a:xfrm>
-            <a:off x="886968" y="1316736"/>
-            <a:ext cx="10424160" cy="3456432"/>
+            <a:off x="1069848" y="1316736"/>
+            <a:ext cx="10058400" cy="3337560"/>
           </a:xfrm>
           <a:prstGeom prst="rect">
             <a:avLst/>
@@ -19068,12 +19405,12 @@
         </p:nvSpPr>
         <p:spPr>
           <a:xfrm>
-            <a:off x="548640" y="4846320"/>
-            <a:ext cx="11091672" cy="1463040"/>
+            <a:off x="548640" y="4727448"/>
+            <a:ext cx="11091672" cy="1581912"/>
           </a:xfrm>
           <a:prstGeom prst="roundRect">
             <a:avLst>
-              <a:gd name="adj" fmla="val 3750"/>
+              <a:gd name="adj" fmla="val 3468"/>
             </a:avLst>
           </a:prstGeom>
           <a:solidFill>
@@ -19095,8 +19432,8 @@
         </p:nvSpPr>
         <p:spPr>
           <a:xfrm>
-            <a:off x="804672" y="5047488"/>
-            <a:ext cx="10579608" cy="1097280"/>
+            <a:off x="804672" y="4928616"/>
+            <a:ext cx="10579608" cy="1216152"/>
           </a:xfrm>
           <a:prstGeom prst="rect">
             <a:avLst/>
@@ -19116,7 +19453,7 @@
               <a:buChar char="•"/>
             </a:pPr>
             <a:r>
-              <a:rPr lang="en-US" sz="1050" b="1" dirty="0">
+              <a:rPr lang="en-US" sz="1000" b="1" dirty="0">
                 <a:solidFill>
                   <a:srgbClr val="4493F8"/>
                 </a:solidFill>
@@ -19127,7 +19464,7 @@
               <a:t>1 · Shared</a:t>
             </a:r>
             <a:r>
-              <a:rPr lang="en-US" sz="1050" dirty="0">
+              <a:rPr lang="en-US" sz="1000" dirty="0">
                 <a:solidFill>
                   <a:srgbClr val="E6EDF3"/>
                 </a:solidFill>
@@ -19138,7 +19475,7 @@
               <a:t> per region, lag and channel group: the shape Σ(ℓ) and the drift </a:t>
             </a:r>
             <a:r>
-              <a:rPr lang="en-US" sz="1050" b="1" dirty="0">
+              <a:rPr lang="en-US" sz="1000" b="1" dirty="0">
                 <a:solidFill>
                   <a:srgbClr val="4493F8"/>
                 </a:solidFill>
@@ -19149,7 +19486,7 @@
               <a:t>d</a:t>
             </a:r>
             <a:r>
-              <a:rPr lang="en-US" sz="1050" dirty="0">
+              <a:rPr lang="en-US" sz="1000" dirty="0">
                 <a:solidFill>
                   <a:srgbClr val="E6EDF3"/>
                 </a:solidFill>
@@ -19160,7 +19497,7 @@
               <a:t> of slide 8. Everything the water carries is carried the same way — the arrow toward the source and the elongation along the jet are properties of the </a:t>
             </a:r>
             <a:r>
-              <a:rPr lang="en-US" sz="1050" b="1" dirty="0">
+              <a:rPr lang="en-US" sz="1000" b="1" dirty="0">
                 <a:solidFill>
                   <a:srgbClr val="4493F8"/>
                 </a:solidFill>
@@ -19171,7 +19508,7 @@
               <a:t>flow</a:t>
             </a:r>
             <a:r>
-              <a:rPr lang="en-US" sz="1050" dirty="0">
+              <a:rPr lang="en-US" sz="1000" dirty="0">
                 <a:solidFill>
                   <a:srgbClr val="E6EDF3"/>
                 </a:solidFill>
@@ -19182,7 +19519,7 @@
               <a:t>, not of the tracer. </a:t>
             </a:r>
             <a:r>
-              <a:rPr lang="en-US" sz="1050" i="1" dirty="0">
+              <a:rPr lang="en-US" sz="1000" i="1" dirty="0">
                 <a:solidFill>
                   <a:srgbClr val="E3B341"/>
                 </a:solidFill>
@@ -19192,7 +19529,7 @@
               </a:rPr>
               <a:t>One direction per flow.</a:t>
             </a:r>
-            <a:endParaRPr lang="en-US" sz="1050" dirty="0"/>
+            <a:endParaRPr lang="en-US" sz="1000" dirty="0"/>
           </a:p>
           <a:p>
             <a:pPr marL="203200" indent="-203200">
@@ -19203,7 +19540,7 @@
               <a:buChar char="•"/>
             </a:pPr>
             <a:r>
-              <a:rPr lang="en-US" sz="1050" b="1" dirty="0">
+              <a:rPr lang="en-US" sz="1000" b="1" dirty="0">
                 <a:solidFill>
                   <a:srgbClr val="4493F8"/>
                 </a:solidFill>
@@ -19214,18 +19551,40 @@
               <a:t>2 · Per channel</a:t>
             </a:r>
             <a:r>
-              <a:rPr lang="en-US" sz="1050" dirty="0">
-                <a:solidFill>
-                  <a:srgbClr val="E6EDF3"/>
-                </a:solidFill>
-                <a:latin typeface="Calibri" pitchFamily="34" charset="0"/>
-                <a:ea typeface="Calibri" pitchFamily="34" charset="-122"/>
-                <a:cs typeface="Calibri" pitchFamily="34" charset="-120"/>
-              </a:rPr>
-              <a:t>: one log-scale offset s</a:t>
-            </a:r>
-            <a:r>
-              <a:rPr lang="en-US" sz="1050" baseline="-40000" dirty="0">
+              <a:rPr lang="en-US" sz="1000" dirty="0">
+                <a:solidFill>
+                  <a:srgbClr val="E6EDF3"/>
+                </a:solidFill>
+                <a:latin typeface="Calibri" pitchFamily="34" charset="0"/>
+                <a:ea typeface="Calibri" pitchFamily="34" charset="-122"/>
+                <a:cs typeface="Calibri" pitchFamily="34" charset="-120"/>
+              </a:rPr>
+              <a:t>: two log-parameters — a </a:t>
+            </a:r>
+            <a:r>
+              <a:rPr lang="en-US" sz="1000" b="1" dirty="0">
+                <a:solidFill>
+                  <a:srgbClr val="4493F8"/>
+                </a:solidFill>
+                <a:latin typeface="Calibri" pitchFamily="34" charset="0"/>
+                <a:ea typeface="Calibri" pitchFamily="34" charset="-122"/>
+                <a:cs typeface="Calibri" pitchFamily="34" charset="-120"/>
+              </a:rPr>
+              <a:t>scale</a:t>
+            </a:r>
+            <a:r>
+              <a:rPr lang="en-US" sz="1000" dirty="0">
+                <a:solidFill>
+                  <a:srgbClr val="E6EDF3"/>
+                </a:solidFill>
+                <a:latin typeface="Calibri" pitchFamily="34" charset="0"/>
+                <a:ea typeface="Calibri" pitchFamily="34" charset="-122"/>
+                <a:cs typeface="Calibri" pitchFamily="34" charset="-120"/>
+              </a:rPr>
+              <a:t> s</a:t>
+            </a:r>
+            <a:r>
+              <a:rPr lang="en-US" sz="1000" baseline="-40000" dirty="0">
                 <a:solidFill>
                   <a:srgbClr val="E6EDF3"/>
                 </a:solidFill>
@@ -19236,18 +19595,40 @@
               <a:t>c</a:t>
             </a:r>
             <a:r>
-              <a:rPr lang="en-US" sz="1050" dirty="0">
-                <a:solidFill>
-                  <a:srgbClr val="E6EDF3"/>
-                </a:solidFill>
-                <a:latin typeface="Calibri" pitchFamily="34" charset="0"/>
-                <a:ea typeface="Calibri" pitchFamily="34" charset="-122"/>
-                <a:cs typeface="Calibri" pitchFamily="34" charset="-120"/>
-              </a:rPr>
-              <a:t> (two for the L-shaped channels: lags 0–1 and 2–6). S</a:t>
-            </a:r>
-            <a:r>
-              <a:rPr lang="en-US" sz="1050" baseline="-40000" dirty="0">
+              <a:rPr lang="en-US" sz="1000" dirty="0">
+                <a:solidFill>
+                  <a:srgbClr val="E6EDF3"/>
+                </a:solidFill>
+                <a:latin typeface="Calibri" pitchFamily="34" charset="0"/>
+                <a:ea typeface="Calibri" pitchFamily="34" charset="-122"/>
+                <a:cs typeface="Calibri" pitchFamily="34" charset="-120"/>
+              </a:rPr>
+              <a:t> (two for the L-shaped channels: lags 0–1 and 2–6) and a </a:t>
+            </a:r>
+            <a:r>
+              <a:rPr lang="en-US" sz="1000" b="1" dirty="0">
+                <a:solidFill>
+                  <a:srgbClr val="4493F8"/>
+                </a:solidFill>
+                <a:latin typeface="Calibri" pitchFamily="34" charset="0"/>
+                <a:ea typeface="Calibri" pitchFamily="34" charset="-122"/>
+                <a:cs typeface="Calibri" pitchFamily="34" charset="-120"/>
+              </a:rPr>
+              <a:t>memory</a:t>
+            </a:r>
+            <a:r>
+              <a:rPr lang="en-US" sz="1000" dirty="0">
+                <a:solidFill>
+                  <a:srgbClr val="E6EDF3"/>
+                </a:solidFill>
+                <a:latin typeface="Calibri" pitchFamily="34" charset="0"/>
+                <a:ea typeface="Calibri" pitchFamily="34" charset="-122"/>
+                <a:cs typeface="Calibri" pitchFamily="34" charset="-120"/>
+              </a:rPr>
+              <a:t> τ</a:t>
+            </a:r>
+            <a:r>
+              <a:rPr lang="en-US" sz="1000" baseline="-40000" dirty="0">
                 <a:solidFill>
                   <a:srgbClr val="E6EDF3"/>
                 </a:solidFill>
@@ -19258,7 +19639,29 @@
               <a:t>c</a:t>
             </a:r>
             <a:r>
-              <a:rPr lang="en-US" sz="1050" dirty="0">
+              <a:rPr lang="en-US" sz="1000" dirty="0">
+                <a:solidFill>
+                  <a:srgbClr val="E6EDF3"/>
+                </a:solidFill>
+                <a:latin typeface="Calibri" pitchFamily="34" charset="0"/>
+                <a:ea typeface="Calibri" pitchFamily="34" charset="-122"/>
+                <a:cs typeface="Calibri" pitchFamily="34" charset="-120"/>
+              </a:rPr>
+              <a:t>. In space, S</a:t>
+            </a:r>
+            <a:r>
+              <a:rPr lang="en-US" sz="1000" baseline="-40000" dirty="0">
+                <a:solidFill>
+                  <a:srgbClr val="E6EDF3"/>
+                </a:solidFill>
+                <a:latin typeface="Calibri" pitchFamily="34" charset="0"/>
+                <a:ea typeface="Calibri" pitchFamily="34" charset="-122"/>
+                <a:cs typeface="Calibri" pitchFamily="34" charset="-120"/>
+              </a:rPr>
+              <a:t>c</a:t>
+            </a:r>
+            <a:r>
+              <a:rPr lang="en-US" sz="1000" dirty="0">
                 <a:solidFill>
                   <a:srgbClr val="E6EDF3"/>
                 </a:solidFill>
@@ -19269,7 +19672,7 @@
               <a:t>(ℓ) = S(ℓ) + s</a:t>
             </a:r>
             <a:r>
-              <a:rPr lang="en-US" sz="1050" baseline="-40000" dirty="0">
+              <a:rPr lang="en-US" sz="1000" baseline="-40000" dirty="0">
                 <a:solidFill>
                   <a:srgbClr val="E6EDF3"/>
                 </a:solidFill>
@@ -19280,7 +19683,7 @@
               <a:t>c</a:t>
             </a:r>
             <a:r>
-              <a:rPr lang="en-US" sz="1050" dirty="0">
+              <a:rPr lang="en-US" sz="1000" dirty="0">
                 <a:solidFill>
                   <a:srgbClr val="E6EDF3"/>
                 </a:solidFill>
@@ -19291,7 +19694,7 @@
               <a:t>·I, i.e. Σ</a:t>
             </a:r>
             <a:r>
-              <a:rPr lang="en-US" sz="1050" baseline="-40000" dirty="0">
+              <a:rPr lang="en-US" sz="1000" baseline="-40000" dirty="0">
                 <a:solidFill>
                   <a:srgbClr val="E6EDF3"/>
                 </a:solidFill>
@@ -19302,7 +19705,7 @@
               <a:t>c</a:t>
             </a:r>
             <a:r>
-              <a:rPr lang="en-US" sz="1050" dirty="0">
+              <a:rPr lang="en-US" sz="1000" dirty="0">
                 <a:solidFill>
                   <a:srgbClr val="E6EDF3"/>
                 </a:solidFill>
@@ -19313,7 +19716,7 @@
               <a:t>(ℓ) = exp(s</a:t>
             </a:r>
             <a:r>
-              <a:rPr lang="en-US" sz="1050" baseline="-40000" dirty="0">
+              <a:rPr lang="en-US" sz="1000" baseline="-40000" dirty="0">
                 <a:solidFill>
                   <a:srgbClr val="E6EDF3"/>
                 </a:solidFill>
@@ -19324,7 +19727,7 @@
               <a:t>c</a:t>
             </a:r>
             <a:r>
-              <a:rPr lang="en-US" sz="1050" dirty="0">
+              <a:rPr lang="en-US" sz="1000" dirty="0">
                 <a:solidFill>
                   <a:srgbClr val="E6EDF3"/>
                 </a:solidFill>
@@ -19335,7 +19738,7 @@
               <a:t>) · Σ(ℓ) — the same ellipse inflated or shrunk, </a:t>
             </a:r>
             <a:r>
-              <a:rPr lang="en-US" sz="1050" b="1" dirty="0">
+              <a:rPr lang="en-US" sz="1000" b="1" dirty="0">
                 <a:solidFill>
                   <a:srgbClr val="4493F8"/>
                 </a:solidFill>
@@ -19346,18 +19749,40 @@
               <a:t>never turned</a:t>
             </a:r>
             <a:r>
-              <a:rPr lang="en-US" sz="1050" dirty="0">
-                <a:solidFill>
-                  <a:srgbClr val="E6EDF3"/>
-                </a:solidFill>
-                <a:latin typeface="Calibri" pitchFamily="34" charset="0"/>
-                <a:ea typeface="Calibri" pitchFamily="34" charset="-122"/>
-                <a:cs typeface="Calibri" pitchFamily="34" charset="-120"/>
-              </a:rPr>
-              <a:t>. </a:t>
-            </a:r>
-            <a:r>
-              <a:rPr lang="en-US" sz="1050" i="1" dirty="0">
+              <a:rPr lang="en-US" sz="1000" dirty="0">
+                <a:solidFill>
+                  <a:srgbClr val="E6EDF3"/>
+                </a:solidFill>
+                <a:latin typeface="Calibri" pitchFamily="34" charset="0"/>
+                <a:ea typeface="Calibri" pitchFamily="34" charset="-122"/>
+                <a:cs typeface="Calibri" pitchFamily="34" charset="-120"/>
+              </a:rPr>
+              <a:t>. In time, lag ℓ is weighted by exp(−ℓΔt/τ</a:t>
+            </a:r>
+            <a:r>
+              <a:rPr lang="en-US" sz="1000" baseline="-40000" dirty="0">
+                <a:solidFill>
+                  <a:srgbClr val="E6EDF3"/>
+                </a:solidFill>
+                <a:latin typeface="Calibri" pitchFamily="34" charset="0"/>
+                <a:ea typeface="Calibri" pitchFamily="34" charset="-122"/>
+                <a:cs typeface="Calibri" pitchFamily="34" charset="-120"/>
+              </a:rPr>
+              <a:t>c</a:t>
+            </a:r>
+            <a:r>
+              <a:rPr lang="en-US" sz="1000" dirty="0">
+                <a:solidFill>
+                  <a:srgbClr val="E6EDF3"/>
+                </a:solidFill>
+                <a:latin typeface="Calibri" pitchFamily="34" charset="0"/>
+                <a:ea typeface="Calibri" pitchFamily="34" charset="-122"/>
+                <a:cs typeface="Calibri" pitchFamily="34" charset="-120"/>
+              </a:rPr>
+              <a:t>) — how far back this channel is worth reading. </a:t>
+            </a:r>
+            <a:r>
+              <a:rPr lang="en-US" sz="1000" i="1" dirty="0">
                 <a:solidFill>
                   <a:srgbClr val="E3B341"/>
                 </a:solidFill>
@@ -19365,9 +19790,9 @@
                 <a:ea typeface="Calibri" pitchFamily="34" charset="-122"/>
                 <a:cs typeface="Calibri" pitchFamily="34" charset="-120"/>
               </a:rPr>
-              <a:t>One scale per channel.</a:t>
-            </a:r>
-            <a:endParaRPr lang="en-US" sz="1050" dirty="0"/>
+              <a:t>One scale and one memory per channel; the aperture is a space-time object.</a:t>
+            </a:r>
+            <a:endParaRPr lang="en-US" sz="1000" dirty="0"/>
           </a:p>
           <a:p>
             <a:pPr marL="203200" indent="-203200">
@@ -19378,7 +19803,7 @@
               <a:buChar char="•"/>
             </a:pPr>
             <a:r>
-              <a:rPr lang="en-US" sz="1050" b="1" dirty="0">
+              <a:rPr lang="en-US" sz="1000" b="1" dirty="0">
                 <a:solidFill>
                   <a:srgbClr val="4493F8"/>
                 </a:solidFill>
@@ -19386,10 +19811,10 @@
                 <a:ea typeface="Calibri" pitchFamily="34" charset="-122"/>
                 <a:cs typeface="Calibri" pitchFamily="34" charset="-120"/>
               </a:rPr>
-              <a:t>3 · Initialised from the reach table</a:t>
-            </a:r>
-            <a:r>
-              <a:rPr lang="en-US" sz="1050" dirty="0">
+              <a:t>3 · Initialised from the reach-and-memory table</a:t>
+            </a:r>
+            <a:r>
+              <a:rPr lang="en-US" sz="1000" dirty="0">
                 <a:solidFill>
                   <a:srgbClr val="E6EDF3"/>
                 </a:solidFill>
@@ -19400,7 +19825,7 @@
               <a:t> in </a:t>
             </a:r>
             <a:r>
-              <a:rPr lang="en-US" sz="1050" u="sng" dirty="0">
+              <a:rPr lang="en-US" sz="1000" u="sng" dirty="0">
                 <a:solidFill>
                   <a:srgbClr val="4493F8"/>
                 </a:solidFill>
@@ -19418,17 +19843,39 @@
               <a:t>ml/cone.py::FAMILIES</a:t>
             </a:r>
             <a:r>
-              <a:rPr lang="en-US" sz="1050" dirty="0">
-                <a:solidFill>
-                  <a:srgbClr val="E6EDF3"/>
-                </a:solidFill>
-                <a:latin typeface="Calibri" pitchFamily="34" charset="0"/>
-                <a:ea typeface="Calibri" pitchFamily="34" charset="-122"/>
-                <a:cs typeface="Calibri" pitchFamily="34" charset="-120"/>
-              </a:rPr>
-              <a:t>: wind stress 500 km at lags 0–1 and nothing beyond; currents and sea-surface height 129.6 km·(1 + ℓ); sea-surface temperature and mixed-layer depth max(that, 500 km) at lags ≤ 1, then the ocean's growth; land 400 km flat. At step 0 every channel reads the reach the current geometry gives it</a:t>
-            </a:r>
-            <a:endParaRPr lang="en-US" sz="1050" dirty="0"/>
+              <a:rPr lang="en-US" sz="1000" dirty="0">
+                <a:solidFill>
+                  <a:srgbClr val="E6EDF3"/>
+                </a:solidFill>
+                <a:latin typeface="Calibri" pitchFamily="34" charset="0"/>
+                <a:ea typeface="Calibri" pitchFamily="34" charset="-122"/>
+                <a:cs typeface="Calibri" pitchFamily="34" charset="-120"/>
+              </a:rPr>
+              <a:t>: wind stress 500 km with τ = 10 days (lags 0–1 count; lag 6 is at e</a:t>
+            </a:r>
+            <a:r>
+              <a:rPr lang="en-US" sz="1000" baseline="30000" dirty="0">
+                <a:solidFill>
+                  <a:srgbClr val="E6EDF3"/>
+                </a:solidFill>
+                <a:latin typeface="Calibri" pitchFamily="34" charset="0"/>
+                <a:ea typeface="Calibri" pitchFamily="34" charset="-122"/>
+                <a:cs typeface="Calibri" pitchFamily="34" charset="-120"/>
+              </a:rPr>
+              <a:t>−3</a:t>
+            </a:r>
+            <a:r>
+              <a:rPr lang="en-US" sz="1000" dirty="0">
+                <a:solidFill>
+                  <a:srgbClr val="E6EDF3"/>
+                </a:solidFill>
+                <a:latin typeface="Calibri" pitchFamily="34" charset="0"/>
+                <a:ea typeface="Calibri" pitchFamily="34" charset="-122"/>
+                <a:cs typeface="Calibri" pitchFamily="34" charset="-120"/>
+              </a:rPr>
+              <a:t>); currents and sea-surface height 129.6 km·(1 + ℓ), long memory; sea-surface temperature and mixed-layer depth max(that, 500 km) at lags ≤ 1, then the ocean's growth; land 400 km flat, long memory. At step 0 every channel reads the reach and the lags the current geometry gives it</a:t>
+            </a:r>
+            <a:endParaRPr lang="en-US" sz="1000" dirty="0"/>
           </a:p>
         </p:txBody>
       </p:sp>

</xml_diff>